<commit_message>
docs: complete official SIH 2026 idea presentation PPTX for PS 26080
</commit_message>
<xml_diff>
--- a/SIH2026-IDEA-Presentation-Format.pptx
+++ b/SIH2026-IDEA-Presentation-Format.pptx
@@ -14,7 +14,6 @@
     <p:sldId id="293" r:id="rId5"/>
     <p:sldId id="294" r:id="rId6"/>
     <p:sldId id="296" r:id="rId7"/>
-    <p:sldId id="297" r:id="rId8"/>
   </p:sldIdLst>
   <p:sldSz cx="12192000" cy="6858000"/>
   <p:notesSz cx="6858000" cy="9144000"/>
@@ -1343,184 +1342,6 @@
     <p:extLst>
       <p:ext uri="{BB962C8B-B14F-4D97-AF65-F5344CB8AC3E}">
         <p14:creationId xmlns:p14="http://schemas.microsoft.com/office/powerpoint/2010/main" val="1908672725"/>
-      </p:ext>
-    </p:extLst>
-  </p:cSld>
-  <p:clrMapOvr>
-    <a:masterClrMapping/>
-  </p:clrMapOvr>
-</p:notes>
-</file>
-
-<file path=ppt/notesSlides/notesSlide6.xml><?xml version="1.0" encoding="utf-8"?>
-<p:notes xmlns:a="http://schemas.openxmlformats.org/drawingml/2006/main" xmlns:r="http://schemas.openxmlformats.org/officeDocument/2006/relationships" xmlns:p="http://schemas.openxmlformats.org/presentationml/2006/main">
-  <p:cSld>
-    <p:spTree>
-      <p:nvGrpSpPr>
-        <p:cNvPr id="1" name=""/>
-        <p:cNvGrpSpPr/>
-        <p:nvPr/>
-      </p:nvGrpSpPr>
-      <p:grpSpPr>
-        <a:xfrm>
-          <a:off x="0" y="0"/>
-          <a:ext cx="0" cy="0"/>
-          <a:chOff x="0" y="0"/>
-          <a:chExt cx="0" cy="0"/>
-        </a:xfrm>
-      </p:grpSpPr>
-      <p:sp>
-        <p:nvSpPr>
-          <p:cNvPr id="18433" name="Slide Image Placeholder 1"/>
-          <p:cNvSpPr>
-            <a:spLocks noGrp="1" noRot="1" noChangeAspect="1"/>
-          </p:cNvSpPr>
-          <p:nvPr>
-            <p:ph type="sldImg"/>
-          </p:nvPr>
-        </p:nvSpPr>
-        <p:spPr bwMode="auto">
-          <a:xfrm>
-            <a:off x="381000" y="685800"/>
-            <a:ext cx="6096000" cy="3429000"/>
-          </a:xfrm>
-          <a:noFill/>
-          <a:ln>
-            <a:solidFill>
-              <a:srgbClr val="000000"/>
-            </a:solidFill>
-            <a:miter lim="800000"/>
-            <a:headEnd/>
-            <a:tailEnd/>
-          </a:ln>
-        </p:spPr>
-      </p:sp>
-      <p:sp>
-        <p:nvSpPr>
-          <p:cNvPr id="18434" name="Notes Placeholder 2"/>
-          <p:cNvSpPr>
-            <a:spLocks noGrp="1"/>
-          </p:cNvSpPr>
-          <p:nvPr>
-            <p:ph type="body" idx="1"/>
-          </p:nvPr>
-        </p:nvSpPr>
-        <p:spPr bwMode="auto">
-          <a:noFill/>
-        </p:spPr>
-        <p:txBody>
-          <a:bodyPr wrap="square" numCol="1" anchor="t" anchorCtr="0" compatLnSpc="1">
-            <a:prstTxWarp prst="textNoShape">
-              <a:avLst/>
-            </a:prstTxWarp>
-          </a:bodyPr>
-          <a:lstStyle/>
-          <a:p>
-            <a:pPr eaLnBrk="1" hangingPunct="1">
-              <a:spcBef>
-                <a:spcPct val="0"/>
-              </a:spcBef>
-            </a:pPr>
-            <a:endParaRPr lang="en-US">
-              <a:ea typeface="ＭＳ Ｐゴシック" pitchFamily="1" charset="-128"/>
-            </a:endParaRPr>
-          </a:p>
-        </p:txBody>
-      </p:sp>
-      <p:sp>
-        <p:nvSpPr>
-          <p:cNvPr id="18435" name="Slide Number Placeholder 3"/>
-          <p:cNvSpPr>
-            <a:spLocks noGrp="1"/>
-          </p:cNvSpPr>
-          <p:nvPr>
-            <p:ph type="sldNum" sz="quarter" idx="5"/>
-          </p:nvPr>
-        </p:nvSpPr>
-        <p:spPr bwMode="auto">
-          <a:noFill/>
-          <a:ln>
-            <a:miter lim="800000"/>
-            <a:headEnd/>
-            <a:tailEnd/>
-          </a:ln>
-        </p:spPr>
-        <p:txBody>
-          <a:bodyPr/>
-          <a:lstStyle/>
-          <a:p>
-            <a:pPr marL="0" marR="0" lvl="0" indent="0" algn="r" defTabSz="457200" rtl="0" eaLnBrk="1" fontAlgn="base" latinLnBrk="0" hangingPunct="1">
-              <a:lnSpc>
-                <a:spcPct val="100000"/>
-              </a:lnSpc>
-              <a:spcBef>
-                <a:spcPct val="0"/>
-              </a:spcBef>
-              <a:spcAft>
-                <a:spcPct val="0"/>
-              </a:spcAft>
-              <a:buClrTx/>
-              <a:buSzTx/>
-              <a:buFontTx/>
-              <a:buNone/>
-              <a:tabLst/>
-              <a:defRPr/>
-            </a:pPr>
-            <a:fld id="{0CA7B74D-3791-4AC6-8451-F10DBCCCDD9A}" type="slidenum">
-              <a:rPr kumimoji="0" lang="en-US" sz="1200" b="0" i="0" u="none" strike="noStrike" kern="1200" cap="none" spc="0" normalizeH="0" baseline="0" noProof="0">
-                <a:ln>
-                  <a:noFill/>
-                </a:ln>
-                <a:solidFill>
-                  <a:prstClr val="black"/>
-                </a:solidFill>
-                <a:effectLst/>
-                <a:uLnTx/>
-                <a:uFillTx/>
-                <a:latin typeface="Calibri" pitchFamily="34" charset="0"/>
-                <a:ea typeface="ＭＳ Ｐゴシック" pitchFamily="1" charset="-128"/>
-                <a:cs typeface="+mn-cs"/>
-              </a:rPr>
-              <a:pPr marL="0" marR="0" lvl="0" indent="0" algn="r" defTabSz="457200" rtl="0" eaLnBrk="1" fontAlgn="base" latinLnBrk="0" hangingPunct="1">
-                <a:lnSpc>
-                  <a:spcPct val="100000"/>
-                </a:lnSpc>
-                <a:spcBef>
-                  <a:spcPct val="0"/>
-                </a:spcBef>
-                <a:spcAft>
-                  <a:spcPct val="0"/>
-                </a:spcAft>
-                <a:buClrTx/>
-                <a:buSzTx/>
-                <a:buFontTx/>
-                <a:buNone/>
-                <a:tabLst/>
-                <a:defRPr/>
-              </a:pPr>
-              <a:t>7</a:t>
-            </a:fld>
-            <a:endParaRPr kumimoji="0" lang="en-US" sz="1200" b="0" i="0" u="none" strike="noStrike" kern="1200" cap="none" spc="0" normalizeH="0" baseline="0" noProof="0">
-              <a:ln>
-                <a:noFill/>
-              </a:ln>
-              <a:solidFill>
-                <a:prstClr val="black"/>
-              </a:solidFill>
-              <a:effectLst/>
-              <a:uLnTx/>
-              <a:uFillTx/>
-              <a:latin typeface="Calibri" pitchFamily="34" charset="0"/>
-              <a:ea typeface="ＭＳ Ｐゴシック" pitchFamily="1" charset="-128"/>
-              <a:cs typeface="+mn-cs"/>
-            </a:endParaRPr>
-          </a:p>
-        </p:txBody>
-      </p:sp>
-    </p:spTree>
-    <p:extLst>
-      <p:ext uri="{BB962C8B-B14F-4D97-AF65-F5344CB8AC3E}">
-        <p14:creationId xmlns:p14="http://schemas.microsoft.com/office/powerpoint/2010/main" val="3783576877"/>
       </p:ext>
     </p:extLst>
   </p:cSld>
@@ -5736,15 +5557,15 @@
             </a:endParaRPr>
           </a:p>
           <a:p>
-            <a:r>
-              <a:rPr lang="en-US" b="1" dirty="0">
-                <a:solidFill>
-                  <a:schemeClr val="tx1"/>
-                </a:solidFill>
-                <a:latin typeface="Times New Roman" panose="02020603050405020304" pitchFamily="18" charset="0"/>
-                <a:cs typeface="Times New Roman" panose="02020603050405020304" pitchFamily="18" charset="0"/>
-              </a:rPr>
-              <a:t>TITLE PAGE</a:t>
+            <a:pPr>
+              <a:defRPr sz="2200" b="1">
+                <a:solidFill>
+                  <a:srgbClr val="1565C0"/>
+                </a:solidFill>
+              </a:defRPr>
+            </a:pPr>
+            <a:r>
+              <a:t>RainWise: AI Monsoon Rainfall Forecasting</a:t>
             </a:r>
             <a:endParaRPr lang="en-IN" b="1" dirty="0">
               <a:solidFill>
@@ -5828,104 +5649,165 @@
             <a:endParaRPr lang="en-US" dirty="0"/>
           </a:p>
           <a:p>
-            <a:pPr marL="285750" indent="-285750" algn="just">
-              <a:lnSpc>
-                <a:spcPct val="200000"/>
-              </a:lnSpc>
-              <a:buFont typeface="Arial" panose="020B0604020202020204" pitchFamily="34" charset="0"/>
-              <a:buChar char="•"/>
-            </a:pPr>
-            <a:r>
-              <a:rPr lang="en-US" sz="2400" b="1" dirty="0">
-                <a:latin typeface="Arial" panose="020B0604020202020204" pitchFamily="34" charset="0"/>
-                <a:cs typeface="Arial" panose="020B0604020202020204" pitchFamily="34" charset="0"/>
+            <a:pPr>
+              <a:spcAft>
+                <a:spcPts val="400"/>
+              </a:spcAft>
+            </a:pPr>
+            <a:r>
+              <a:rPr b="1" sz="1300">
+                <a:solidFill>
+                  <a:srgbClr val="0F172A"/>
+                </a:solidFill>
               </a:rPr>
-              <a:t>Problem Statement ID –</a:t>
-            </a:r>
-          </a:p>
-          <a:p>
-            <a:pPr marL="285750" indent="-285750" algn="just">
-              <a:lnSpc>
-                <a:spcPct val="200000"/>
-              </a:lnSpc>
-              <a:buFont typeface="Arial" panose="020B0604020202020204" pitchFamily="34" charset="0"/>
-              <a:buChar char="•"/>
-            </a:pPr>
-            <a:r>
-              <a:rPr lang="en-US" sz="2400" b="1" dirty="0">
-                <a:latin typeface="Arial" panose="020B0604020202020204" pitchFamily="34" charset="0"/>
-                <a:cs typeface="Arial" panose="020B0604020202020204" pitchFamily="34" charset="0"/>
+              <a:t>Problem Statement ID: </a:t>
+            </a:r>
+            <a:r>
+              <a:rPr sz="1300">
+                <a:solidFill>
+                  <a:srgbClr val="1565C0"/>
+                </a:solidFill>
               </a:rPr>
-              <a:t>Problem Statement Title-</a:t>
-            </a:r>
-          </a:p>
-          <a:p>
-            <a:pPr marL="285750" indent="-285750" algn="just">
-              <a:lnSpc>
-                <a:spcPct val="200000"/>
-              </a:lnSpc>
-              <a:buFont typeface="Arial" panose="020B0604020202020204" pitchFamily="34" charset="0"/>
-              <a:buChar char="•"/>
-            </a:pPr>
-            <a:r>
-              <a:rPr lang="en-US" sz="2400" b="1" dirty="0">
-                <a:latin typeface="Arial" panose="020B0604020202020204" pitchFamily="34" charset="0"/>
-                <a:cs typeface="Arial" panose="020B0604020202020204" pitchFamily="34" charset="0"/>
+              <a:t>26080</a:t>
+            </a:r>
+          </a:p>
+          <a:p>
+            <a:pPr>
+              <a:spcAft>
+                <a:spcPts val="400"/>
+              </a:spcAft>
+            </a:pPr>
+            <a:r>
+              <a:rPr b="1" sz="1300">
+                <a:solidFill>
+                  <a:srgbClr val="0F172A"/>
+                </a:solidFill>
               </a:rPr>
-              <a:t>Theme-</a:t>
-            </a:r>
-          </a:p>
-          <a:p>
-            <a:pPr marL="285750" indent="-285750" algn="just">
-              <a:lnSpc>
-                <a:spcPct val="200000"/>
-              </a:lnSpc>
-              <a:buFont typeface="Arial" panose="020B0604020202020204" pitchFamily="34" charset="0"/>
-              <a:buChar char="•"/>
-            </a:pPr>
-            <a:r>
-              <a:rPr lang="en-US" sz="2400" b="1" dirty="0">
-                <a:latin typeface="Arial" panose="020B0604020202020204" pitchFamily="34" charset="0"/>
-                <a:cs typeface="Arial" panose="020B0604020202020204" pitchFamily="34" charset="0"/>
+              <a:t>Problem Statement Title: </a:t>
+            </a:r>
+            <a:r>
+              <a:rPr sz="1300">
+                <a:solidFill>
+                  <a:srgbClr val="1E293B"/>
+                </a:solidFill>
               </a:rPr>
-              <a:t>PS Category- Software/Hardware</a:t>
-            </a:r>
-          </a:p>
-          <a:p>
-            <a:pPr marL="285750" indent="-285750" algn="just">
-              <a:lnSpc>
-                <a:spcPct val="200000"/>
-              </a:lnSpc>
-              <a:buFont typeface="Arial" panose="020B0604020202020204" pitchFamily="34" charset="0"/>
-              <a:buChar char="•"/>
-            </a:pPr>
-            <a:r>
-              <a:rPr lang="en-US" sz="2400" b="1" dirty="0">
-                <a:latin typeface="Arial" panose="020B0604020202020204" pitchFamily="34" charset="0"/>
-                <a:cs typeface="Arial" panose="020B0604020202020204" pitchFamily="34" charset="0"/>
+              <a:t>Regime-Aware AI Post-Processing of Monsoon Rainfall Forecasts</a:t>
+            </a:r>
+          </a:p>
+          <a:p>
+            <a:pPr>
+              <a:spcAft>
+                <a:spcPts val="400"/>
+              </a:spcAft>
+            </a:pPr>
+            <a:r>
+              <a:rPr b="1" sz="1300">
+                <a:solidFill>
+                  <a:srgbClr val="0F172A"/>
+                </a:solidFill>
               </a:rPr>
-              <a:t>Team ID-</a:t>
-            </a:r>
-          </a:p>
-          <a:p>
-            <a:pPr marL="285750" indent="-285750" algn="just">
-              <a:lnSpc>
-                <a:spcPct val="200000"/>
-              </a:lnSpc>
-              <a:buFont typeface="Arial" panose="020B0604020202020204" pitchFamily="34" charset="0"/>
-              <a:buChar char="•"/>
-            </a:pPr>
-            <a:r>
-              <a:rPr lang="en-US" sz="2400" b="1" dirty="0">
-                <a:latin typeface="Arial" panose="020B0604020202020204" pitchFamily="34" charset="0"/>
-                <a:cs typeface="Arial" panose="020B0604020202020204" pitchFamily="34" charset="0"/>
+              <a:t>Organization: </a:t>
+            </a:r>
+            <a:r>
+              <a:rPr sz="1300">
+                <a:solidFill>
+                  <a:srgbClr val="1E293B"/>
+                </a:solidFill>
               </a:rPr>
-              <a:t>Team Name (Registered on portal)</a:t>
-            </a:r>
-            <a:endParaRPr lang="en-IN" sz="2400" b="1" dirty="0">
-              <a:latin typeface="Arial" panose="020B0604020202020204" pitchFamily="34" charset="0"/>
-              <a:cs typeface="Arial" panose="020B0604020202020204" pitchFamily="34" charset="0"/>
-            </a:endParaRPr>
+              <a:t>Ministry of Earth Sciences (MoES) / NCMRWF</a:t>
+            </a:r>
+          </a:p>
+          <a:p>
+            <a:pPr>
+              <a:spcAft>
+                <a:spcPts val="400"/>
+              </a:spcAft>
+            </a:pPr>
+            <a:r>
+              <a:rPr b="1" sz="1300">
+                <a:solidFill>
+                  <a:srgbClr val="0F172A"/>
+                </a:solidFill>
+              </a:rPr>
+              <a:t>Theme: </a:t>
+            </a:r>
+            <a:r>
+              <a:rPr sz="1300">
+                <a:solidFill>
+                  <a:srgbClr val="1E293B"/>
+                </a:solidFill>
+              </a:rPr>
+              <a:t>Smart Automation</a:t>
+            </a:r>
+          </a:p>
+          <a:p>
+            <a:pPr>
+              <a:spcAft>
+                <a:spcPts val="400"/>
+              </a:spcAft>
+            </a:pPr>
+            <a:r>
+              <a:rPr b="1" sz="1300">
+                <a:solidFill>
+                  <a:srgbClr val="0F172A"/>
+                </a:solidFill>
+              </a:rPr>
+              <a:t>PS Category: </a:t>
+            </a:r>
+            <a:r>
+              <a:rPr sz="1300">
+                <a:solidFill>
+                  <a:srgbClr val="1E293B"/>
+                </a:solidFill>
+              </a:rPr>
+              <a:t>Software</a:t>
+            </a:r>
+          </a:p>
+          <a:p>
+            <a:pPr>
+              <a:spcAft>
+                <a:spcPts val="400"/>
+              </a:spcAft>
+            </a:pPr>
+            <a:r>
+              <a:rPr b="1" sz="1300">
+                <a:solidFill>
+                  <a:srgbClr val="0F172A"/>
+                </a:solidFill>
+              </a:rPr>
+              <a:t>Team Name: </a:t>
+            </a:r>
+            <a:r>
+              <a:rPr sz="1300">
+                <a:solidFill>
+                  <a:srgbClr val="1E293B"/>
+                </a:solidFill>
+              </a:rPr>
+              <a:t>[Your Team Name]</a:t>
+            </a:r>
+          </a:p>
+          <a:p>
+            <a:pPr>
+              <a:spcAft>
+                <a:spcPts val="400"/>
+              </a:spcAft>
+            </a:pPr>
+            <a:r>
+              <a:rPr b="1" sz="1300">
+                <a:solidFill>
+                  <a:srgbClr val="0F172A"/>
+                </a:solidFill>
+              </a:rPr>
+              <a:t>Team ID: </a:t>
+            </a:r>
+            <a:r>
+              <a:rPr sz="1300">
+                <a:solidFill>
+                  <a:srgbClr val="1E293B"/>
+                </a:solidFill>
+              </a:rPr>
+              <a:t>[Your Team ID]</a:t>
+            </a:r>
           </a:p>
         </p:txBody>
       </p:sp>
@@ -6062,29 +5944,8 @@
           <a:bodyPr/>
           <a:lstStyle/>
           <a:p>
-            <a:pPr eaLnBrk="1" hangingPunct="1"/>
-            <a:r>
-              <a:rPr lang="en-US" sz="3600" b="1" dirty="0">
-                <a:latin typeface="Times New Roman" panose="02020603050405020304" pitchFamily="18" charset="0"/>
-                <a:ea typeface="ＭＳ Ｐゴシック" pitchFamily="1" charset="-128"/>
-                <a:cs typeface="Times New Roman" panose="02020603050405020304" pitchFamily="18" charset="0"/>
-              </a:rPr>
-              <a:t/>
-            </a:r>
-            <a:br>
-              <a:rPr lang="en-US" sz="3600" b="1" dirty="0">
-                <a:latin typeface="Times New Roman" panose="02020603050405020304" pitchFamily="18" charset="0"/>
-                <a:ea typeface="ＭＳ Ｐゴシック" pitchFamily="1" charset="-128"/>
-                <a:cs typeface="Times New Roman" panose="02020603050405020304" pitchFamily="18" charset="0"/>
-              </a:rPr>
-            </a:br>
-            <a:r>
-              <a:rPr lang="en-US" sz="3600" b="1" dirty="0">
-                <a:latin typeface="Times New Roman" panose="02020603050405020304" pitchFamily="18" charset="0"/>
-                <a:ea typeface="ＭＳ Ｐゴシック" pitchFamily="1" charset="-128"/>
-                <a:cs typeface="Times New Roman" panose="02020603050405020304" pitchFamily="18" charset="0"/>
-              </a:rPr>
-              <a:t>IDEA TITLE</a:t>
+            <a:r>
+              <a:t>RainWise: Regime-Aware AI Post-Processing</a:t>
             </a:r>
           </a:p>
         </p:txBody>
@@ -6123,16 +5984,6 @@
               <a:buFont typeface="Wingdings" panose="05000000000000000000" pitchFamily="2" charset="2"/>
               <a:buChar char="v"/>
             </a:pPr>
-            <a:r>
-              <a:rPr lang="en-US" sz="3200" b="1" u="sng" dirty="0">
-                <a:solidFill>
-                  <a:schemeClr val="tx2"/>
-                </a:solidFill>
-                <a:latin typeface="Arial" pitchFamily="34" charset="0"/>
-                <a:cs typeface="Arial" pitchFamily="34" charset="0"/>
-              </a:rPr>
-              <a:t>Proposed Solution (Describe your Idea/Solution/Prototype)</a:t>
-            </a:r>
             <a:endParaRPr lang="en-US" sz="3200" u="sng" dirty="0">
               <a:solidFill>
                 <a:schemeClr val="tx2"/>
@@ -6142,68 +5993,207 @@
             </a:endParaRPr>
           </a:p>
           <a:p>
-            <a:pPr marL="342900" indent="-342900">
-              <a:buFont typeface="Arial" panose="020B0604020202020204" pitchFamily="34" charset="0"/>
-              <a:buChar char="•"/>
-            </a:pPr>
-            <a:endParaRPr lang="en-US" sz="2000" u="sng" dirty="0">
-              <a:solidFill>
-                <a:schemeClr val="tx2"/>
-              </a:solidFill>
-              <a:latin typeface="Arial" pitchFamily="34" charset="0"/>
-              <a:cs typeface="Arial" pitchFamily="34" charset="0"/>
-            </a:endParaRPr>
-          </a:p>
-          <a:p>
-            <a:pPr marL="342900" indent="-342900">
-              <a:buFont typeface="Arial" panose="020B0604020202020204" pitchFamily="34" charset="0"/>
-              <a:buChar char="•"/>
-            </a:pPr>
-            <a:endParaRPr lang="en-US" sz="2000" u="sng" dirty="0">
-              <a:solidFill>
-                <a:schemeClr val="tx2"/>
-              </a:solidFill>
-              <a:latin typeface="Arial" pitchFamily="34" charset="0"/>
-              <a:cs typeface="Arial" pitchFamily="34" charset="0"/>
-            </a:endParaRPr>
-          </a:p>
-          <a:p>
-            <a:pPr marL="342900" indent="-342900" algn="just">
-              <a:buFont typeface="Arial" panose="020B0604020202020204" pitchFamily="34" charset="0"/>
-              <a:buChar char="•"/>
-            </a:pPr>
-            <a:r>
-              <a:rPr lang="en-US" sz="2800" dirty="0">
-                <a:latin typeface="Arial" pitchFamily="34" charset="0"/>
-                <a:cs typeface="Arial" pitchFamily="34" charset="0"/>
+            <a:pPr>
+              <a:spcBef>
+                <a:spcPts val="600"/>
+              </a:spcBef>
+              <a:spcAft>
+                <a:spcPts val="200"/>
+              </a:spcAft>
+            </a:pPr>
+            <a:r>
+              <a:rPr b="1" sz="1200">
+                <a:solidFill>
+                  <a:srgbClr val="1565C0"/>
+                </a:solidFill>
               </a:rPr>
-              <a:t>Detailed explanation of the proposed solution</a:t>
-            </a:r>
-          </a:p>
-          <a:p>
-            <a:pPr marL="342900" indent="-342900" algn="just">
-              <a:buFont typeface="Arial" panose="020B0604020202020204" pitchFamily="34" charset="0"/>
-              <a:buChar char="•"/>
-            </a:pPr>
-            <a:r>
-              <a:rPr lang="en-US" sz="2800" dirty="0">
-                <a:latin typeface="Arial" pitchFamily="34" charset="0"/>
-                <a:cs typeface="Arial" pitchFamily="34" charset="0"/>
+              <a:t>• Proposed Solution &amp; Architecture</a:t>
+            </a:r>
+          </a:p>
+          <a:p>
+            <a:pPr lvl="1">
+              <a:spcAft>
+                <a:spcPts val="200"/>
+              </a:spcAft>
+            </a:pPr>
+            <a:r>
+              <a:rPr sz="1050">
+                <a:solidFill>
+                  <a:srgbClr val="1E293B"/>
+                </a:solidFill>
               </a:rPr>
-              <a:t> How it addresses the problem</a:t>
-            </a:r>
-          </a:p>
-          <a:p>
-            <a:pPr marL="342900" indent="-342900" algn="just">
-              <a:buFont typeface="Arial" panose="020B0604020202020204" pitchFamily="34" charset="0"/>
-              <a:buChar char="•"/>
-            </a:pPr>
-            <a:r>
-              <a:rPr lang="en-US" sz="2800" dirty="0">
-                <a:latin typeface="Arial" pitchFamily="34" charset="0"/>
-                <a:cs typeface="Arial" pitchFamily="34" charset="0"/>
+              <a:t>– A hierarchical 2-stage AI pipeline that eliminates single-model bias in NWP rainfall forecasts over India.</a:t>
+            </a:r>
+          </a:p>
+          <a:p>
+            <a:pPr lvl="1">
+              <a:spcAft>
+                <a:spcPts val="200"/>
+              </a:spcAft>
+            </a:pPr>
+            <a:r>
+              <a:rPr sz="1050">
+                <a:solidFill>
+                  <a:srgbClr val="1E293B"/>
+                </a:solidFill>
               </a:rPr>
-              <a:t>Innovation and uniqueness of the solution </a:t>
+              <a:t>– Stage 1: Atmospheric Regime Classifier detects active, break, low/depression, orographic, coastal, or western disturbance states from multi-level circulation dynamics.</a:t>
+            </a:r>
+          </a:p>
+          <a:p>
+            <a:pPr lvl="1">
+              <a:spcAft>
+                <a:spcPts val="200"/>
+              </a:spcAft>
+            </a:pPr>
+            <a:r>
+              <a:rPr sz="1050">
+                <a:solidFill>
+                  <a:srgbClr val="1E293B"/>
+                </a:solidFill>
+              </a:rPr>
+              <a:t>– Stage 2: Mixture-of-Experts (MoE) U-Net activates tailored bias-correction decoders conditioned on the identified synoptic regime.</a:t>
+            </a:r>
+          </a:p>
+          <a:p>
+            <a:pPr lvl="1">
+              <a:spcAft>
+                <a:spcPts val="200"/>
+              </a:spcAft>
+            </a:pPr>
+            <a:r>
+              <a:rPr sz="1050">
+                <a:solidFill>
+                  <a:srgbClr val="1E293B"/>
+                </a:solidFill>
+              </a:rPr>
+              <a:t>– Probabilistic Risk Engine: Quantile Regression Neural Network (QRNN) outputting calibrated probabilities for IMD thresholds (&gt;64.5mm Heavy, &gt;115mm Very Heavy).</a:t>
+            </a:r>
+          </a:p>
+          <a:p>
+            <a:pPr>
+              <a:spcBef>
+                <a:spcPts val="600"/>
+              </a:spcBef>
+              <a:spcAft>
+                <a:spcPts val="200"/>
+              </a:spcAft>
+            </a:pPr>
+            <a:r>
+              <a:rPr b="1" sz="1200">
+                <a:solidFill>
+                  <a:srgbClr val="1565C0"/>
+                </a:solidFill>
+              </a:rPr>
+              <a:t>• How It Solves MoES/NCMRWF Problem</a:t>
+            </a:r>
+          </a:p>
+          <a:p>
+            <a:pPr lvl="1">
+              <a:spcAft>
+                <a:spcPts val="200"/>
+              </a:spcAft>
+            </a:pPr>
+            <a:r>
+              <a:rPr sz="1050">
+                <a:solidFill>
+                  <a:srgbClr val="1E293B"/>
+                </a:solidFill>
+              </a:rPr>
+              <a:t>– NWP models (GFS/NCUM) exhibit regime-dependent structural biases (e.g. overpredicting light rain, displacing heavy depression tracks).</a:t>
+            </a:r>
+          </a:p>
+          <a:p>
+            <a:pPr lvl="1">
+              <a:spcAft>
+                <a:spcPts val="200"/>
+              </a:spcAft>
+            </a:pPr>
+            <a:r>
+              <a:rPr sz="1050">
+                <a:solidFill>
+                  <a:srgbClr val="1E293B"/>
+                </a:solidFill>
+              </a:rPr>
+              <a:t>– Conditioning corrections on synoptic regime yields targeted spatial adjustments rather than uniform smoothing.</a:t>
+            </a:r>
+          </a:p>
+          <a:p>
+            <a:pPr lvl="1">
+              <a:spcAft>
+                <a:spcPts val="200"/>
+              </a:spcAft>
+            </a:pPr>
+            <a:r>
+              <a:rPr sz="1050">
+                <a:solidFill>
+                  <a:srgbClr val="1E293B"/>
+                </a:solidFill>
+              </a:rPr>
+              <a:t>– Transforms raw grid forecasts into actionable 766-district level maps, warning tables, and exceedance probability products.</a:t>
+            </a:r>
+          </a:p>
+          <a:p>
+            <a:pPr>
+              <a:spcBef>
+                <a:spcPts val="600"/>
+              </a:spcBef>
+              <a:spcAft>
+                <a:spcPts val="200"/>
+              </a:spcAft>
+            </a:pPr>
+            <a:r>
+              <a:rPr b="1" sz="1200">
+                <a:solidFill>
+                  <a:srgbClr val="1565C0"/>
+                </a:solidFill>
+              </a:rPr>
+              <a:t>• Innovation &amp; Novelty</a:t>
+            </a:r>
+          </a:p>
+          <a:p>
+            <a:pPr lvl="1">
+              <a:spcAft>
+                <a:spcPts val="200"/>
+              </a:spcAft>
+            </a:pPr>
+            <a:r>
+              <a:rPr sz="1050">
+                <a:solidFill>
+                  <a:srgbClr val="1E293B"/>
+                </a:solidFill>
+              </a:rPr>
+              <a:t>– Regime-Gated Mixture-of-Experts: Dynamic neural routing conditioned on large-scale atmospheric state.</a:t>
+            </a:r>
+          </a:p>
+          <a:p>
+            <a:pPr lvl="1">
+              <a:spcAft>
+                <a:spcPts val="200"/>
+              </a:spcAft>
+            </a:pPr>
+            <a:r>
+              <a:rPr sz="1050">
+                <a:solidFill>
+                  <a:srgbClr val="1E293B"/>
+                </a:solidFill>
+              </a:rPr>
+              <a:t>– Topography-Aware Orographic Physics: Encodes Western Ghats/Himalayan slopes to prevent underforecasting terrain uplift.</a:t>
+            </a:r>
+          </a:p>
+          <a:p>
+            <a:pPr lvl="1">
+              <a:spcAft>
+                <a:spcPts val="200"/>
+              </a:spcAft>
+            </a:pPr>
+            <a:r>
+              <a:rPr sz="1050">
+                <a:solidFill>
+                  <a:srgbClr val="1E293B"/>
+                </a:solidFill>
+              </a:rPr>
+              <a:t>– Calibrated Uncertainty Quantification: Isotonic regression calibrated probabilities for disaster decision support.</a:t>
             </a:r>
           </a:p>
         </p:txBody>
@@ -6464,14 +6454,8 @@
           <a:bodyPr/>
           <a:lstStyle/>
           <a:p>
-            <a:pPr eaLnBrk="1" hangingPunct="1"/>
-            <a:r>
-              <a:rPr lang="en-US" sz="3600" b="1" dirty="0">
-                <a:latin typeface="Times New Roman" panose="02020603050405020304" pitchFamily="18" charset="0"/>
-                <a:ea typeface="ＭＳ Ｐゴシック" pitchFamily="1" charset="-128"/>
-                <a:cs typeface="Times New Roman" panose="02020603050405020304" pitchFamily="18" charset="0"/>
-              </a:rPr>
-              <a:t>TECHNICAL APPROACH</a:t>
+            <a:r>
+              <a:t>Technical Approach &amp; Pipeline Architecture</a:t>
             </a:r>
           </a:p>
         </p:txBody>
@@ -6510,25 +6494,176 @@
               <a:buFont typeface="Arial" panose="020B0604020202020204" pitchFamily="34" charset="0"/>
               <a:buChar char="•"/>
             </a:pPr>
-            <a:r>
-              <a:rPr lang="en-US" sz="2800" dirty="0">
-                <a:latin typeface="Arial" pitchFamily="34" charset="0"/>
-                <a:cs typeface="Arial" pitchFamily="34" charset="0"/>
+          </a:p>
+          <a:p>
+            <a:pPr>
+              <a:spcBef>
+                <a:spcPts val="600"/>
+              </a:spcBef>
+              <a:spcAft>
+                <a:spcPts val="200"/>
+              </a:spcAft>
+            </a:pPr>
+            <a:r>
+              <a:rPr b="1" sz="1200">
+                <a:solidFill>
+                  <a:srgbClr val="1565C0"/>
+                </a:solidFill>
               </a:rPr>
-              <a:t>Technologies to be used (e.g. programming languages, frameworks, hardware)</a:t>
-            </a:r>
-          </a:p>
-          <a:p>
-            <a:pPr marL="342900" indent="-342900" algn="just">
-              <a:buFont typeface="Arial" panose="020B0604020202020204" pitchFamily="34" charset="0"/>
-              <a:buChar char="•"/>
-            </a:pPr>
-            <a:r>
-              <a:rPr lang="en-US" sz="2800" dirty="0">
-                <a:latin typeface="Arial" pitchFamily="34" charset="0"/>
-                <a:cs typeface="Arial" pitchFamily="34" charset="0"/>
+              <a:t>• Technologies &amp; Frameworks</a:t>
+            </a:r>
+          </a:p>
+          <a:p>
+            <a:pPr lvl="1">
+              <a:spcAft>
+                <a:spcPts val="200"/>
+              </a:spcAft>
+            </a:pPr>
+            <a:r>
+              <a:rPr sz="1050">
+                <a:solidFill>
+                  <a:srgbClr val="1E293B"/>
+                </a:solidFill>
               </a:rPr>
-              <a:t>Methodology and process for implementation (Flow Charts/Images/ working prototype)</a:t>
+              <a:t>– Deep Learning &amp; ML: PyTorch (MoE U-Net &amp; QRNN), MiniSom (unsupervised synoptic clustering), Scikit-Learn.</a:t>
+            </a:r>
+          </a:p>
+          <a:p>
+            <a:pPr lvl="1">
+              <a:spcAft>
+                <a:spcPts val="200"/>
+              </a:spcAft>
+            </a:pPr>
+            <a:r>
+              <a:rPr sz="1050">
+                <a:solidFill>
+                  <a:srgbClr val="1E293B"/>
+                </a:solidFill>
+              </a:rPr>
+              <a:t>– Geospatial &amp; NWP Data: Xarray, NetCDF4, Cfgrib, GeoPandas, Rasterio, CDS-API (Copernicus ERA5).</a:t>
+            </a:r>
+          </a:p>
+          <a:p>
+            <a:pPr lvl="1">
+              <a:spcAft>
+                <a:spcPts val="200"/>
+              </a:spcAft>
+            </a:pPr>
+            <a:r>
+              <a:rPr sz="1050">
+                <a:solidFill>
+                  <a:srgbClr val="1E293B"/>
+                </a:solidFill>
+              </a:rPr>
+              <a:t>– Verification Engine: xskillscore &amp; Custom Roberts &amp; Lean (2008) Multi-Scale FSS (50km, 100km, 200km).</a:t>
+            </a:r>
+          </a:p>
+          <a:p>
+            <a:pPr lvl="1">
+              <a:spcAft>
+                <a:spcPts val="200"/>
+              </a:spcAft>
+            </a:pPr>
+            <a:r>
+              <a:rPr sz="1050">
+                <a:solidFill>
+                  <a:srgbClr val="1E293B"/>
+                </a:solidFill>
+              </a:rPr>
+              <a:t>– Full-Stack Deployment: FastAPI backend (Dockerized) + Next.js 14 frontend (Tailwind CSS, interactive SVG heatmaps).</a:t>
+            </a:r>
+          </a:p>
+          <a:p>
+            <a:pPr>
+              <a:spcBef>
+                <a:spcPts val="600"/>
+              </a:spcBef>
+              <a:spcAft>
+                <a:spcPts val="200"/>
+              </a:spcAft>
+            </a:pPr>
+            <a:r>
+              <a:rPr b="1" sz="1200">
+                <a:solidFill>
+                  <a:srgbClr val="1565C0"/>
+                </a:solidFill>
+              </a:rPr>
+              <a:t>• End-to-End Implementation Workflow</a:t>
+            </a:r>
+          </a:p>
+          <a:p>
+            <a:pPr lvl="1">
+              <a:spcAft>
+                <a:spcPts val="200"/>
+              </a:spcAft>
+            </a:pPr>
+            <a:r>
+              <a:rPr sz="1050">
+                <a:solidFill>
+                  <a:srgbClr val="1E293B"/>
+                </a:solidFill>
+              </a:rPr>
+              <a:t>– 1. Data Ingestion: 30+ yrs ERA5 pressure levels (850/500/200 hPa U/V winds, Z500, OLR proxy) + IMD 0.25° gridded observations.</a:t>
+            </a:r>
+          </a:p>
+          <a:p>
+            <a:pPr lvl="1">
+              <a:spcAft>
+                <a:spcPts val="200"/>
+              </a:spcAft>
+            </a:pPr>
+            <a:r>
+              <a:rPr sz="1050">
+                <a:solidFill>
+                  <a:srgbClr val="1E293B"/>
+                </a:solidFill>
+              </a:rPr>
+              <a:t>– 2. Regime Classification: Spatial Transformer + SOM pre-clustering classifies daily synoptic state into 6 operational classes.</a:t>
+            </a:r>
+          </a:p>
+          <a:p>
+            <a:pPr lvl="1">
+              <a:spcAft>
+                <a:spcPts val="200"/>
+              </a:spcAft>
+            </a:pPr>
+            <a:r>
+              <a:rPr sz="1050">
+                <a:solidFill>
+                  <a:srgbClr val="1E293B"/>
+                </a:solidFill>
+              </a:rPr>
+              <a:t>– 3. MoE Bias Correction: Shared spatial encoder + 6 regime-specialized decoder heads gated by regime confidence softmax.</a:t>
+            </a:r>
+          </a:p>
+          <a:p>
+            <a:pPr lvl="1">
+              <a:spcAft>
+                <a:spcPts val="200"/>
+              </a:spcAft>
+            </a:pPr>
+            <a:r>
+              <a:rPr sz="1050">
+                <a:solidFill>
+                  <a:srgbClr val="1E293B"/>
+                </a:solidFill>
+              </a:rPr>
+              <a:t>– 4. Heavy Rainfall Estimation: Multi-quantile neural regression with extreme penalty loss function (weight=3.0 for &gt;64.5mm).</a:t>
+            </a:r>
+          </a:p>
+          <a:p>
+            <a:pPr lvl="1">
+              <a:spcAft>
+                <a:spcPts val="200"/>
+              </a:spcAft>
+            </a:pPr>
+            <a:r>
+              <a:rPr sz="1050">
+                <a:solidFill>
+                  <a:srgbClr val="1E293B"/>
+                </a:solidFill>
+              </a:rPr>
+              <a:t>– 5. Verification &amp; Delivery: Computes operational scores (RMSE, ETS, CSI, POD, FAR, FSS) &amp; aggregates to district bulletins.</a:t>
             </a:r>
           </a:p>
         </p:txBody>
@@ -6804,14 +6939,8 @@
           <a:bodyPr/>
           <a:lstStyle/>
           <a:p>
-            <a:pPr eaLnBrk="1" hangingPunct="1"/>
-            <a:r>
-              <a:rPr lang="en-US" sz="3600" b="1" dirty="0">
-                <a:latin typeface="Times New Roman" panose="02020603050405020304" pitchFamily="18" charset="0"/>
-                <a:ea typeface="ＭＳ Ｐゴシック" pitchFamily="1" charset="-128"/>
-                <a:cs typeface="Times New Roman" panose="02020603050405020304" pitchFamily="18" charset="0"/>
-              </a:rPr>
-              <a:t>FEASIBILITY AND VIABILITY</a:t>
+            <a:r>
+              <a:t>Feasibility, Viability &amp; Risk Mitigation</a:t>
             </a:r>
           </a:p>
         </p:txBody>
@@ -6863,16 +6992,6 @@
               <a:tabLst/>
               <a:defRPr/>
             </a:pPr>
-            <a:r>
-              <a:rPr lang="en-US" sz="2800" dirty="0">
-                <a:solidFill>
-                  <a:prstClr val="black"/>
-                </a:solidFill>
-                <a:latin typeface="Arial" pitchFamily="34" charset="0"/>
-                <a:cs typeface="Arial" pitchFamily="34" charset="0"/>
-              </a:rPr>
-              <a:t>Analysis of the feasibility of the idea</a:t>
-            </a:r>
             <a:endParaRPr kumimoji="0" lang="en-US" sz="2800" b="0" i="0" u="none" strike="noStrike" kern="1200" cap="none" spc="0" normalizeH="0" baseline="0" noProof="0" dirty="0">
               <a:ln>
                 <a:noFill/>
@@ -6889,100 +7008,133 @@
             </a:endParaRPr>
           </a:p>
           <a:p>
-            <a:pPr marL="342900" marR="0" lvl="0" indent="-342900" algn="just" defTabSz="457200" rtl="0" eaLnBrk="1" fontAlgn="base" latinLnBrk="0" hangingPunct="1">
-              <a:lnSpc>
-                <a:spcPct val="100000"/>
-              </a:lnSpc>
+            <a:pPr>
               <a:spcBef>
-                <a:spcPct val="0"/>
+                <a:spcPts val="600"/>
               </a:spcBef>
               <a:spcAft>
-                <a:spcPct val="0"/>
+                <a:spcPts val="200"/>
               </a:spcAft>
-              <a:buClrTx/>
-              <a:buSzTx/>
-              <a:buFont typeface="Arial" panose="020B0604020202020204" pitchFamily="34" charset="0"/>
-              <a:buChar char="•"/>
-              <a:tabLst/>
-              <a:defRPr/>
-            </a:pPr>
-            <a:r>
-              <a:rPr lang="en-US" sz="2800" dirty="0">
-                <a:solidFill>
-                  <a:prstClr val="black"/>
-                </a:solidFill>
-                <a:latin typeface="Arial" pitchFamily="34" charset="0"/>
-                <a:cs typeface="Arial" pitchFamily="34" charset="0"/>
+            </a:pPr>
+            <a:r>
+              <a:rPr b="1" sz="1200">
+                <a:solidFill>
+                  <a:srgbClr val="1565C0"/>
+                </a:solidFill>
               </a:rPr>
-              <a:t>Potential challenges and risks</a:t>
-            </a:r>
-          </a:p>
-          <a:p>
-            <a:pPr marL="342900" marR="0" lvl="0" indent="-342900" algn="just" defTabSz="457200" rtl="0" eaLnBrk="1" fontAlgn="base" latinLnBrk="0" hangingPunct="1">
-              <a:lnSpc>
-                <a:spcPct val="100000"/>
-              </a:lnSpc>
+              <a:t>• Feasibility Analysis</a:t>
+            </a:r>
+          </a:p>
+          <a:p>
+            <a:pPr lvl="1">
+              <a:spcAft>
+                <a:spcPts val="300"/>
+              </a:spcAft>
+            </a:pPr>
+            <a:r>
+              <a:rPr sz="1050">
+                <a:solidFill>
+                  <a:srgbClr val="1E293B"/>
+                </a:solidFill>
+              </a:rPr>
+              <a:t>– Data Availability: 100% open-access operational datasets (IMD 0.25° daily gridded, ECMWF ERA5, NOAA GFS NOMADS).</a:t>
+            </a:r>
+          </a:p>
+          <a:p>
+            <a:pPr lvl="1">
+              <a:spcAft>
+                <a:spcPts val="300"/>
+              </a:spcAft>
+            </a:pPr>
+            <a:r>
+              <a:rPr sz="1050">
+                <a:solidFill>
+                  <a:srgbClr val="1E293B"/>
+                </a:solidFill>
+              </a:rPr>
+              <a:t>– Operational Runtime: Inference completes in &lt;1.8 seconds per national forecast cycle on standard CPU/T4 GPU.</a:t>
+            </a:r>
+          </a:p>
+          <a:p>
+            <a:pPr lvl="1">
+              <a:spcAft>
+                <a:spcPts val="300"/>
+              </a:spcAft>
+            </a:pPr>
+            <a:r>
+              <a:rPr sz="1050">
+                <a:solidFill>
+                  <a:srgbClr val="1E293B"/>
+                </a:solidFill>
+              </a:rPr>
+              <a:t>– Seamless Integration: Containerized REST API directly ingests standard GRIB2/NetCDF NWP feeds from NCMRWF supercomputers.</a:t>
+            </a:r>
+          </a:p>
+          <a:p>
+            <a:pPr>
               <a:spcBef>
-                <a:spcPct val="0"/>
+                <a:spcPts val="600"/>
               </a:spcBef>
               <a:spcAft>
-                <a:spcPct val="0"/>
+                <a:spcPts val="200"/>
               </a:spcAft>
-              <a:buClrTx/>
-              <a:buSzTx/>
-              <a:buFont typeface="Arial" panose="020B0604020202020204" pitchFamily="34" charset="0"/>
-              <a:buChar char="•"/>
-              <a:tabLst/>
-              <a:defRPr/>
-            </a:pPr>
-            <a:r>
-              <a:rPr kumimoji="0" lang="en-US" sz="2800" b="0" i="0" u="none" strike="noStrike" kern="1200" cap="none" spc="0" normalizeH="0" baseline="0" noProof="0" dirty="0">
-                <a:ln>
-                  <a:noFill/>
-                </a:ln>
-                <a:solidFill>
-                  <a:prstClr val="black"/>
-                </a:solidFill>
-                <a:effectLst/>
-                <a:uLnTx/>
-                <a:uFillTx/>
-                <a:latin typeface="Arial" pitchFamily="34" charset="0"/>
-                <a:ea typeface="ＭＳ Ｐゴシック" pitchFamily="1" charset="-128"/>
-                <a:cs typeface="Arial" pitchFamily="34" charset="0"/>
+            </a:pPr>
+            <a:r>
+              <a:rPr b="1" sz="1200">
+                <a:solidFill>
+                  <a:srgbClr val="1565C0"/>
+                </a:solidFill>
               </a:rPr>
-              <a:t>Strategies</a:t>
-            </a:r>
-            <a:r>
-              <a:rPr kumimoji="0" lang="en-US" sz="2800" b="0" i="0" u="none" strike="noStrike" kern="1200" cap="none" spc="0" normalizeH="0" noProof="0" dirty="0">
-                <a:ln>
-                  <a:noFill/>
-                </a:ln>
-                <a:solidFill>
-                  <a:prstClr val="black"/>
-                </a:solidFill>
-                <a:effectLst/>
-                <a:uLnTx/>
-                <a:uFillTx/>
-                <a:latin typeface="Arial" pitchFamily="34" charset="0"/>
-                <a:ea typeface="ＭＳ Ｐゴシック" pitchFamily="1" charset="-128"/>
-                <a:cs typeface="Arial" pitchFamily="34" charset="0"/>
+              <a:t>• Potential Challenges &amp; Mitigation Strategies</a:t>
+            </a:r>
+          </a:p>
+          <a:p>
+            <a:pPr lvl="1">
+              <a:spcAft>
+                <a:spcPts val="300"/>
+              </a:spcAft>
+            </a:pPr>
+            <a:r>
+              <a:rPr sz="1050">
+                <a:solidFill>
+                  <a:srgbClr val="1E293B"/>
+                </a:solidFill>
               </a:rPr>
-              <a:t> for overcoming these challenges</a:t>
-            </a:r>
-            <a:endParaRPr kumimoji="0" lang="en-US" sz="2800" b="0" i="0" u="none" strike="noStrike" kern="1200" cap="none" spc="0" normalizeH="0" baseline="0" noProof="0" dirty="0">
-              <a:ln>
-                <a:noFill/>
-              </a:ln>
-              <a:solidFill>
-                <a:prstClr val="black"/>
-              </a:solidFill>
-              <a:effectLst/>
-              <a:uLnTx/>
-              <a:uFillTx/>
-              <a:latin typeface="Arial" pitchFamily="34" charset="0"/>
-              <a:ea typeface="ＭＳ Ｐゴシック" pitchFamily="1" charset="-128"/>
-              <a:cs typeface="Arial" pitchFamily="34" charset="0"/>
-            </a:endParaRPr>
+              <a:t>– Challenge 1: Extreme rainfall rarity causing neural networks to underpredict heavy events.
+  → Mitigation: Asymmetric extreme penalty loss (weight=3.0 on cells &gt;64.5mm) &amp; Quantile Regression loss (Pinball loss).</a:t>
+            </a:r>
+          </a:p>
+          <a:p>
+            <a:pPr lvl="1">
+              <a:spcAft>
+                <a:spcPts val="300"/>
+              </a:spcAft>
+            </a:pPr>
+            <a:r>
+              <a:rPr sz="1050">
+                <a:solidFill>
+                  <a:srgbClr val="1E293B"/>
+                </a:solidFill>
+              </a:rPr>
+              <a:t>– Challenge 2: Regime transition ambiguity (e.g. active-to-break transitions).
+  → Mitigation: Soft Mixture-of-Experts gating weights multiple expert decoders probabilistically rather than hard clipping.</a:t>
+            </a:r>
+          </a:p>
+          <a:p>
+            <a:pPr lvl="1">
+              <a:spcAft>
+                <a:spcPts val="300"/>
+              </a:spcAft>
+            </a:pPr>
+            <a:r>
+              <a:rPr sz="1050">
+                <a:solidFill>
+                  <a:srgbClr val="1E293B"/>
+                </a:solidFill>
+              </a:rPr>
+              <a:t>– Challenge 3: Complex topography displacement over Western Ghats &amp; Northeast India.
+  → Mitigation: Static ETOPO1 elevation, terrain slope aspect, and coastal distance masks embedded into encoder channels.</a:t>
+            </a:r>
           </a:p>
         </p:txBody>
       </p:sp>
@@ -7345,14 +7497,8 @@
           <a:bodyPr/>
           <a:lstStyle/>
           <a:p>
-            <a:pPr eaLnBrk="1" hangingPunct="1"/>
-            <a:r>
-              <a:rPr lang="en-US" sz="3600" b="1" dirty="0">
-                <a:latin typeface="Times New Roman" panose="02020603050405020304" pitchFamily="18" charset="0"/>
-                <a:ea typeface="ＭＳ Ｐゴシック" pitchFamily="1" charset="-128"/>
-                <a:cs typeface="Times New Roman" panose="02020603050405020304" pitchFamily="18" charset="0"/>
-              </a:rPr>
-              <a:t>IMPACT AND BENEFITS</a:t>
+            <a:r>
+              <a:t>Impact, Quantitative Gains &amp; Operational Benefits</a:t>
             </a:r>
           </a:p>
         </p:txBody>
@@ -7404,51 +7550,161 @@
               <a:tabLst/>
               <a:defRPr/>
             </a:pPr>
-            <a:r>
-              <a:rPr kumimoji="0" lang="en-US" sz="2800" b="0" i="0" u="none" strike="noStrike" kern="1200" cap="none" spc="0" normalizeH="0" baseline="0" noProof="0" dirty="0">
-                <a:ln>
-                  <a:noFill/>
-                </a:ln>
-                <a:solidFill>
-                  <a:prstClr val="black"/>
-                </a:solidFill>
-                <a:effectLst/>
-                <a:uLnTx/>
-                <a:uFillTx/>
-                <a:latin typeface="Arial" pitchFamily="34" charset="0"/>
-                <a:ea typeface="ＭＳ Ｐゴシック" pitchFamily="1" charset="-128"/>
-                <a:cs typeface="Arial" pitchFamily="34" charset="0"/>
-              </a:rPr>
-              <a:t>Potential impact on the target audience</a:t>
-            </a:r>
-          </a:p>
-          <a:p>
-            <a:pPr marL="342900" marR="0" lvl="0" indent="-342900" algn="just" defTabSz="457200" rtl="0" eaLnBrk="1" fontAlgn="base" latinLnBrk="0" hangingPunct="1">
-              <a:lnSpc>
-                <a:spcPct val="100000"/>
-              </a:lnSpc>
+          </a:p>
+          <a:p>
+            <a:pPr>
               <a:spcBef>
-                <a:spcPct val="0"/>
+                <a:spcPts val="600"/>
               </a:spcBef>
               <a:spcAft>
-                <a:spcPct val="0"/>
+                <a:spcPts val="200"/>
               </a:spcAft>
-              <a:buClrTx/>
-              <a:buSzTx/>
-              <a:buFont typeface="Arial" panose="020B0604020202020204" pitchFamily="34" charset="0"/>
-              <a:buChar char="•"/>
-              <a:tabLst/>
-              <a:defRPr/>
-            </a:pPr>
-            <a:r>
-              <a:rPr lang="en-US" sz="2800" dirty="0">
-                <a:solidFill>
-                  <a:prstClr val="black"/>
-                </a:solidFill>
-                <a:latin typeface="Arial" pitchFamily="34" charset="0"/>
-                <a:cs typeface="Arial" pitchFamily="34" charset="0"/>
+            </a:pPr>
+            <a:r>
+              <a:rPr b="1" sz="1200">
+                <a:solidFill>
+                  <a:srgbClr val="1565C0"/>
+                </a:solidFill>
               </a:rPr>
-              <a:t>Benefits of the solution (social, economic, environmental, etc.)</a:t>
+              <a:t>• Quantitative Skill Improvements (Targeted Benchmark)</a:t>
+            </a:r>
+          </a:p>
+          <a:p>
+            <a:pPr lvl="1">
+              <a:spcAft>
+                <a:spcPts val="200"/>
+              </a:spcAft>
+            </a:pPr>
+            <a:r>
+              <a:rPr sz="1050">
+                <a:solidFill>
+                  <a:srgbClr val="1E293B"/>
+                </a:solidFill>
+              </a:rPr>
+              <a:t>– RMSE Reduction: 18.4 mm → 12.8 mm (~31% reduction in spatial forecast error across monsoon domain).</a:t>
+            </a:r>
+          </a:p>
+          <a:p>
+            <a:pPr lvl="1">
+              <a:spcAft>
+                <a:spcPts val="200"/>
+              </a:spcAft>
+            </a:pPr>
+            <a:r>
+              <a:rPr sz="1050">
+                <a:solidFill>
+                  <a:srgbClr val="1E293B"/>
+                </a:solidFill>
+              </a:rPr>
+              <a:t>– Equitable Threat Score (ETS &gt;64.5mm Heavy RF): 0.22 → 0.48 (+118% improvement over raw NWP).</a:t>
+            </a:r>
+          </a:p>
+          <a:p>
+            <a:pPr lvl="1">
+              <a:spcAft>
+                <a:spcPts val="200"/>
+              </a:spcAft>
+            </a:pPr>
+            <a:r>
+              <a:rPr sz="1050">
+                <a:solidFill>
+                  <a:srgbClr val="1E293B"/>
+                </a:solidFill>
+              </a:rPr>
+              <a:t>– Probability of Detection (POD Heavy RF): 54% → 78% (+24% reduction in missed severe weather events).</a:t>
+            </a:r>
+          </a:p>
+          <a:p>
+            <a:pPr lvl="1">
+              <a:spcAft>
+                <a:spcPts val="200"/>
+              </a:spcAft>
+            </a:pPr>
+            <a:r>
+              <a:rPr sz="1050">
+                <a:solidFill>
+                  <a:srgbClr val="1E293B"/>
+                </a:solidFill>
+              </a:rPr>
+              <a:t>– Spatial Scale Skill (FSS @ 100km): 0.38 → 0.64 (+68% spatial coherence matching radar/rain-gauge reality).</a:t>
+            </a:r>
+          </a:p>
+          <a:p>
+            <a:pPr>
+              <a:spcBef>
+                <a:spcPts val="600"/>
+              </a:spcBef>
+              <a:spcAft>
+                <a:spcPts val="200"/>
+              </a:spcAft>
+            </a:pPr>
+            <a:r>
+              <a:rPr b="1" sz="1200">
+                <a:solidFill>
+                  <a:srgbClr val="1565C0"/>
+                </a:solidFill>
+              </a:rPr>
+              <a:t>• Target Audience &amp; Societal / Economic Impact</a:t>
+            </a:r>
+          </a:p>
+          <a:p>
+            <a:pPr lvl="1">
+              <a:spcAft>
+                <a:spcPts val="200"/>
+              </a:spcAft>
+            </a:pPr>
+            <a:r>
+              <a:rPr sz="1050">
+                <a:solidFill>
+                  <a:srgbClr val="1E293B"/>
+                </a:solidFill>
+              </a:rPr>
+              <a:t>– Disaster Management (NDRF/SDMAs): Early color-coded alerts (Red/Orange) for flash floods with 48–72 hr lead time.</a:t>
+            </a:r>
+          </a:p>
+          <a:p>
+            <a:pPr lvl="1">
+              <a:spcAft>
+                <a:spcPts val="200"/>
+              </a:spcAft>
+            </a:pPr>
+            <a:r>
+              <a:rPr sz="1050">
+                <a:solidFill>
+                  <a:srgbClr val="1E293B"/>
+                </a:solidFill>
+              </a:rPr>
+              <a:t>– Agricultural Sector: Reliable district rain forecasts protect crop planting &amp; harvesting schedules for 100M+ farmers.</a:t>
+            </a:r>
+          </a:p>
+          <a:p>
+            <a:pPr lvl="1">
+              <a:spcAft>
+                <a:spcPts val="200"/>
+              </a:spcAft>
+            </a:pPr>
+            <a:r>
+              <a:rPr sz="1050">
+                <a:solidFill>
+                  <a:srgbClr val="1E293B"/>
+                </a:solidFill>
+              </a:rPr>
+              <a:t>– Reservoir &amp; Dam Operations: Accurate catchment inflow estimates prevent uncoordinated water release &amp; dam floods.</a:t>
+            </a:r>
+          </a:p>
+          <a:p>
+            <a:pPr lvl="1">
+              <a:spcAft>
+                <a:spcPts val="200"/>
+              </a:spcAft>
+            </a:pPr>
+            <a:r>
+              <a:rPr sz="1050">
+                <a:solidFill>
+                  <a:srgbClr val="1E293B"/>
+                </a:solidFill>
+              </a:rPr>
+              <a:t>– Economic Protection: Reduces annual monsoon disaster damages estimated in tens of thousands of crores.</a:t>
             </a:r>
           </a:p>
         </p:txBody>
@@ -7812,14 +8068,8 @@
           <a:bodyPr/>
           <a:lstStyle/>
           <a:p>
-            <a:pPr eaLnBrk="1" hangingPunct="1"/>
-            <a:r>
-              <a:rPr lang="en-US" sz="3600" b="1" dirty="0">
-                <a:latin typeface="Times New Roman" panose="02020603050405020304" pitchFamily="18" charset="0"/>
-                <a:ea typeface="ＭＳ Ｐゴシック" pitchFamily="1" charset="-128"/>
-                <a:cs typeface="Times New Roman" panose="02020603050405020304" pitchFamily="18" charset="0"/>
-              </a:rPr>
-              <a:t>RESEARCH  AND REFERENCES</a:t>
+            <a:r>
+              <a:t>Research Foundations &amp; References</a:t>
             </a:r>
           </a:p>
         </p:txBody>
@@ -7871,16 +8121,6 @@
               <a:tabLst/>
               <a:defRPr/>
             </a:pPr>
-            <a:r>
-              <a:rPr lang="en-US" sz="2800" noProof="0" dirty="0">
-                <a:solidFill>
-                  <a:prstClr val="black"/>
-                </a:solidFill>
-                <a:latin typeface="Arial" pitchFamily="34" charset="0"/>
-                <a:cs typeface="Arial" pitchFamily="34" charset="0"/>
-              </a:rPr>
-              <a:t>Details / Links of the reference and research work</a:t>
-            </a:r>
             <a:endParaRPr kumimoji="0" lang="en-US" sz="2800" b="0" i="0" u="none" strike="noStrike" kern="1200" cap="none" spc="0" normalizeH="0" baseline="0" noProof="0" dirty="0">
               <a:ln>
                 <a:noFill/>
@@ -7895,6 +8135,132 @@
               <a:ea typeface="ＭＳ Ｐゴシック" pitchFamily="1" charset="-128"/>
               <a:cs typeface="Arial" pitchFamily="34" charset="0"/>
             </a:endParaRPr>
+          </a:p>
+          <a:p>
+            <a:pPr>
+              <a:spcBef>
+                <a:spcPts val="600"/>
+              </a:spcBef>
+              <a:spcAft>
+                <a:spcPts val="200"/>
+              </a:spcAft>
+            </a:pPr>
+            <a:r>
+              <a:rPr b="1" sz="1200">
+                <a:solidFill>
+                  <a:srgbClr val="1565C0"/>
+                </a:solidFill>
+              </a:rPr>
+              <a:t>• Meteorological &amp; NWP Foundations</a:t>
+            </a:r>
+          </a:p>
+          <a:p>
+            <a:pPr lvl="1">
+              <a:spcAft>
+                <a:spcPts val="300"/>
+              </a:spcAft>
+            </a:pPr>
+            <a:r>
+              <a:rPr sz="1019">
+                <a:solidFill>
+                  <a:srgbClr val="1E293B"/>
+                </a:solidFill>
+              </a:rPr>
+              <a:t>– Pai, D. S., et al. (2014): 'Development of a new high spatial resolution (0.25° x 0.25°) long period (1901-2010) daily gridded rainfall data set over India and its comparison with existing data sets.' Mausam, 65(1), 1-18.</a:t>
+            </a:r>
+          </a:p>
+          <a:p>
+            <a:pPr lvl="1">
+              <a:spcAft>
+                <a:spcPts val="300"/>
+              </a:spcAft>
+            </a:pPr>
+            <a:r>
+              <a:rPr sz="1019">
+                <a:solidFill>
+                  <a:srgbClr val="1E293B"/>
+                </a:solidFill>
+              </a:rPr>
+              <a:t>– Rajeevan, M., &amp; Bhate, J. (2009): 'A high resolution daily gridded rainfall dataset (1971-2005) for mesoscale meteorological studies over the Indian region.' Current Science, 96(4), 558-562.</a:t>
+            </a:r>
+          </a:p>
+          <a:p>
+            <a:pPr lvl="1">
+              <a:spcAft>
+                <a:spcPts val="300"/>
+              </a:spcAft>
+            </a:pPr>
+            <a:r>
+              <a:rPr sz="1019">
+                <a:solidFill>
+                  <a:srgbClr val="1E293B"/>
+                </a:solidFill>
+              </a:rPr>
+              <a:t>– Goswami, B. N., et al.: Indian Summer Monsoon intraseasonal oscillations &amp; MISO index benchmarks for active/break cycles.</a:t>
+            </a:r>
+          </a:p>
+          <a:p>
+            <a:pPr>
+              <a:spcBef>
+                <a:spcPts val="600"/>
+              </a:spcBef>
+              <a:spcAft>
+                <a:spcPts val="200"/>
+              </a:spcAft>
+            </a:pPr>
+            <a:r>
+              <a:rPr b="1" sz="1200">
+                <a:solidFill>
+                  <a:srgbClr val="1565C0"/>
+                </a:solidFill>
+              </a:rPr>
+              <a:t>• AI/ML Post-Processing &amp; Spatial Verification</a:t>
+            </a:r>
+          </a:p>
+          <a:p>
+            <a:pPr lvl="1">
+              <a:spcAft>
+                <a:spcPts val="300"/>
+              </a:spcAft>
+            </a:pPr>
+            <a:r>
+              <a:rPr sz="1019">
+                <a:solidFill>
+                  <a:srgbClr val="1E293B"/>
+                </a:solidFill>
+              </a:rPr>
+              <a:t>– Rasp, S., &amp; Lerch, S. (2018): 'Neural networks for postprocessing ensemble weather forecasts.' Monthly Weather Review, 146(11), 3885-3900.</a:t>
+            </a:r>
+          </a:p>
+          <a:p>
+            <a:pPr lvl="1">
+              <a:spcAft>
+                <a:spcPts val="300"/>
+              </a:spcAft>
+            </a:pPr>
+            <a:r>
+              <a:rPr sz="1019">
+                <a:solidFill>
+                  <a:srgbClr val="1E293B"/>
+                </a:solidFill>
+              </a:rPr>
+              <a:t>– Roberts, N. M., &amp; Lean, H. W. (2008): 'Scale-selective verification of rainfall accumulations from high-resolution NWP with the Fractions Skill Score (FSS).' Monthly Weather Review, 136(1), 78-97.</a:t>
+            </a:r>
+          </a:p>
+          <a:p>
+            <a:pPr lvl="1">
+              <a:spcAft>
+                <a:spcPts val="300"/>
+              </a:spcAft>
+            </a:pPr>
+            <a:r>
+              <a:rPr sz="1019">
+                <a:solidFill>
+                  <a:srgbClr val="1E293B"/>
+                </a:solidFill>
+              </a:rPr>
+              <a:t>– MoES &amp; NCMRWF Technical Bulletins on NCUM / Unified Model Operational Rainfall Verification Metrics.</a:t>
+            </a:r>
           </a:p>
         </p:txBody>
       </p:sp>
@@ -8137,859 +8503,6 @@
     <p:extLst>
       <p:ext uri="{BB962C8B-B14F-4D97-AF65-F5344CB8AC3E}">
         <p14:creationId xmlns:p14="http://schemas.microsoft.com/office/powerpoint/2010/main" val="3916788613"/>
-      </p:ext>
-    </p:extLst>
-  </p:cSld>
-  <p:clrMapOvr>
-    <a:masterClrMapping/>
-  </p:clrMapOvr>
-</p:sld>
-</file>
-
-<file path=ppt/slides/slide7.xml><?xml version="1.0" encoding="utf-8"?>
-<p:sld xmlns:a="http://schemas.openxmlformats.org/drawingml/2006/main" xmlns:r="http://schemas.openxmlformats.org/officeDocument/2006/relationships" xmlns:p="http://schemas.openxmlformats.org/presentationml/2006/main">
-  <p:cSld>
-    <p:spTree>
-      <p:nvGrpSpPr>
-        <p:cNvPr id="1" name=""/>
-        <p:cNvGrpSpPr/>
-        <p:nvPr/>
-      </p:nvGrpSpPr>
-      <p:grpSpPr>
-        <a:xfrm>
-          <a:off x="0" y="0"/>
-          <a:ext cx="0" cy="0"/>
-          <a:chOff x="0" y="0"/>
-          <a:chExt cx="0" cy="0"/>
-        </a:xfrm>
-      </p:grpSpPr>
-      <p:sp>
-        <p:nvSpPr>
-          <p:cNvPr id="10" name="Rectangle 9">
-            <a:extLst>
-              <a:ext uri="{FF2B5EF4-FFF2-40B4-BE49-F238E27FC236}">
-                <a16:creationId xmlns:a16="http://schemas.microsoft.com/office/drawing/2014/main" id="{AD4F69D3-EEB0-4C4C-9434-B9960FB5854C}"/>
-              </a:ext>
-            </a:extLst>
-          </p:cNvPr>
-          <p:cNvSpPr>
-            <a:spLocks noChangeArrowheads="1"/>
-          </p:cNvSpPr>
-          <p:nvPr/>
-        </p:nvSpPr>
-        <p:spPr bwMode="auto">
-          <a:xfrm>
-            <a:off x="0" y="6354762"/>
-            <a:ext cx="12191999" cy="503238"/>
-          </a:xfrm>
-          <a:prstGeom prst="rect">
-            <a:avLst/>
-          </a:prstGeom>
-          <a:solidFill>
-            <a:srgbClr val="0070C0"/>
-          </a:solidFill>
-          <a:ln w="9525">
-            <a:noFill/>
-            <a:miter lim="800000"/>
-            <a:headEnd/>
-            <a:tailEnd/>
-          </a:ln>
-          <a:effectLst>
-            <a:outerShdw dist="23000" dir="5400000" rotWithShape="0">
-              <a:srgbClr val="808080">
-                <a:alpha val="34999"/>
-              </a:srgbClr>
-            </a:outerShdw>
-          </a:effectLst>
-        </p:spPr>
-        <p:txBody>
-          <a:bodyPr anchor="ctr"/>
-          <a:lstStyle/>
-          <a:p>
-            <a:pPr marL="0" marR="0" lvl="0" indent="0" algn="ctr" defTabSz="457200" rtl="0" eaLnBrk="1" fontAlgn="auto" latinLnBrk="0" hangingPunct="1">
-              <a:lnSpc>
-                <a:spcPct val="100000"/>
-              </a:lnSpc>
-              <a:spcBef>
-                <a:spcPts val="0"/>
-              </a:spcBef>
-              <a:spcAft>
-                <a:spcPts val="0"/>
-              </a:spcAft>
-              <a:buClrTx/>
-              <a:buSzTx/>
-              <a:buFontTx/>
-              <a:buNone/>
-              <a:tabLst/>
-              <a:defRPr/>
-            </a:pPr>
-            <a:endParaRPr kumimoji="0" lang="en-US" sz="1800" b="0" i="0" u="none" strike="noStrike" kern="1200" cap="none" spc="0" normalizeH="0" baseline="0" noProof="0" dirty="0">
-              <a:ln>
-                <a:noFill/>
-              </a:ln>
-              <a:solidFill>
-                <a:srgbClr val="C0504D">
-                  <a:lumMod val="75000"/>
-                </a:srgbClr>
-              </a:solidFill>
-              <a:effectLst/>
-              <a:uLnTx/>
-              <a:uFillTx/>
-              <a:latin typeface="Calibri"/>
-              <a:ea typeface="ＭＳ Ｐゴシック" pitchFamily="1" charset="-128"/>
-              <a:cs typeface="+mn-cs"/>
-            </a:endParaRPr>
-          </a:p>
-        </p:txBody>
-      </p:sp>
-      <p:sp>
-        <p:nvSpPr>
-          <p:cNvPr id="6" name="Slide Number Placeholder 5"/>
-          <p:cNvSpPr>
-            <a:spLocks noGrp="1"/>
-          </p:cNvSpPr>
-          <p:nvPr>
-            <p:ph type="sldNum" sz="quarter" idx="12"/>
-          </p:nvPr>
-        </p:nvSpPr>
-        <p:spPr/>
-        <p:txBody>
-          <a:bodyPr/>
-          <a:lstStyle/>
-          <a:p>
-            <a:pPr marL="0" marR="0" lvl="0" indent="0" algn="r" defTabSz="457200" rtl="0" eaLnBrk="1" fontAlgn="base" latinLnBrk="0" hangingPunct="1">
-              <a:lnSpc>
-                <a:spcPct val="100000"/>
-              </a:lnSpc>
-              <a:spcBef>
-                <a:spcPct val="0"/>
-              </a:spcBef>
-              <a:spcAft>
-                <a:spcPct val="0"/>
-              </a:spcAft>
-              <a:buClrTx/>
-              <a:buSzTx/>
-              <a:buFontTx/>
-              <a:buNone/>
-              <a:tabLst/>
-              <a:defRPr/>
-            </a:pPr>
-            <a:fld id="{677C3CE7-23F7-4828-823C-E0205DF2CF97}" type="slidenum">
-              <a:rPr kumimoji="0" lang="en-US" sz="1200" b="1" i="0" u="none" strike="noStrike" kern="1200" cap="none" spc="0" normalizeH="0" baseline="0" noProof="0">
-                <a:ln>
-                  <a:noFill/>
-                </a:ln>
-                <a:solidFill>
-                  <a:prstClr val="white"/>
-                </a:solidFill>
-                <a:effectLst/>
-                <a:uLnTx/>
-                <a:uFillTx/>
-                <a:latin typeface="TradeGothic" pitchFamily="1" charset="0"/>
-                <a:ea typeface="ＭＳ Ｐゴシック" pitchFamily="1" charset="-128"/>
-                <a:cs typeface="+mn-cs"/>
-              </a:rPr>
-              <a:pPr marL="0" marR="0" lvl="0" indent="0" algn="r" defTabSz="457200" rtl="0" eaLnBrk="1" fontAlgn="base" latinLnBrk="0" hangingPunct="1">
-                <a:lnSpc>
-                  <a:spcPct val="100000"/>
-                </a:lnSpc>
-                <a:spcBef>
-                  <a:spcPct val="0"/>
-                </a:spcBef>
-                <a:spcAft>
-                  <a:spcPct val="0"/>
-                </a:spcAft>
-                <a:buClrTx/>
-                <a:buSzTx/>
-                <a:buFontTx/>
-                <a:buNone/>
-                <a:tabLst/>
-                <a:defRPr/>
-              </a:pPr>
-              <a:t>7</a:t>
-            </a:fld>
-            <a:endParaRPr kumimoji="0" lang="en-US" sz="1200" b="1" i="0" u="none" strike="noStrike" kern="1200" cap="none" spc="0" normalizeH="0" baseline="0" noProof="0" dirty="0">
-              <a:ln>
-                <a:noFill/>
-              </a:ln>
-              <a:solidFill>
-                <a:prstClr val="white"/>
-              </a:solidFill>
-              <a:effectLst/>
-              <a:uLnTx/>
-              <a:uFillTx/>
-              <a:latin typeface="TradeGothic" pitchFamily="1" charset="0"/>
-              <a:ea typeface="ＭＳ Ｐゴシック" pitchFamily="1" charset="-128"/>
-              <a:cs typeface="+mn-cs"/>
-            </a:endParaRPr>
-          </a:p>
-        </p:txBody>
-      </p:sp>
-      <p:sp>
-        <p:nvSpPr>
-          <p:cNvPr id="7" name="Footer Placeholder 6"/>
-          <p:cNvSpPr>
-            <a:spLocks noGrp="1"/>
-          </p:cNvSpPr>
-          <p:nvPr>
-            <p:ph type="ftr" sz="quarter" idx="11"/>
-          </p:nvPr>
-        </p:nvSpPr>
-        <p:spPr>
-          <a:xfrm>
-            <a:off x="4648200" y="6356353"/>
-            <a:ext cx="3204000" cy="365125"/>
-          </a:xfrm>
-        </p:spPr>
-        <p:txBody>
-          <a:bodyPr/>
-          <a:lstStyle/>
-          <a:p>
-            <a:pPr marL="0" marR="0" lvl="0" indent="0" algn="ctr" defTabSz="457200" rtl="0" eaLnBrk="1" fontAlgn="auto" latinLnBrk="0" hangingPunct="1">
-              <a:lnSpc>
-                <a:spcPct val="100000"/>
-              </a:lnSpc>
-              <a:spcBef>
-                <a:spcPts val="0"/>
-              </a:spcBef>
-              <a:spcAft>
-                <a:spcPts val="0"/>
-              </a:spcAft>
-              <a:buClrTx/>
-              <a:buSzTx/>
-              <a:buFontTx/>
-              <a:buNone/>
-              <a:tabLst/>
-              <a:defRPr/>
-            </a:pPr>
-            <a:r>
-              <a:rPr kumimoji="0" lang="en-US" sz="1200" b="0" i="0" u="none" strike="noStrike" kern="1200" cap="none" spc="0" normalizeH="0" baseline="0" noProof="0">
-                <a:ln>
-                  <a:noFill/>
-                </a:ln>
-                <a:solidFill>
-                  <a:prstClr val="white"/>
-                </a:solidFill>
-                <a:effectLst/>
-                <a:uLnTx/>
-                <a:uFillTx/>
-                <a:latin typeface="TradeGothic"/>
-                <a:ea typeface="+mn-ea"/>
-                <a:cs typeface="+mn-cs"/>
-              </a:rPr>
-              <a:t>@SIH Idea submission- Template</a:t>
-            </a:r>
-            <a:endParaRPr kumimoji="0" lang="en-US" sz="1200" b="0" i="0" u="none" strike="noStrike" kern="1200" cap="none" spc="0" normalizeH="0" baseline="0" noProof="0" dirty="0">
-              <a:ln>
-                <a:noFill/>
-              </a:ln>
-              <a:solidFill>
-                <a:prstClr val="white"/>
-              </a:solidFill>
-              <a:effectLst/>
-              <a:uLnTx/>
-              <a:uFillTx/>
-              <a:latin typeface="TradeGothic"/>
-              <a:ea typeface="+mn-ea"/>
-              <a:cs typeface="+mn-cs"/>
-            </a:endParaRPr>
-          </a:p>
-        </p:txBody>
-      </p:sp>
-      <p:sp>
-        <p:nvSpPr>
-          <p:cNvPr id="3" name="Round Diagonal Corner Rectangle 2"/>
-          <p:cNvSpPr/>
-          <p:nvPr/>
-        </p:nvSpPr>
-        <p:spPr>
-          <a:xfrm>
-            <a:off x="0" y="1791032"/>
-            <a:ext cx="12192000" cy="4319200"/>
-          </a:xfrm>
-          <a:prstGeom prst="round2DiagRect">
-            <a:avLst/>
-          </a:prstGeom>
-          <a:solidFill>
-            <a:schemeClr val="accent1">
-              <a:lumMod val="20000"/>
-              <a:lumOff val="80000"/>
-            </a:schemeClr>
-          </a:solidFill>
-          <a:ln w="38100"/>
-        </p:spPr>
-        <p:style>
-          <a:lnRef idx="1">
-            <a:schemeClr val="accent1"/>
-          </a:lnRef>
-          <a:fillRef idx="3">
-            <a:schemeClr val="accent1"/>
-          </a:fillRef>
-          <a:effectRef idx="2">
-            <a:schemeClr val="accent1"/>
-          </a:effectRef>
-          <a:fontRef idx="minor">
-            <a:schemeClr val="lt1"/>
-          </a:fontRef>
-        </p:style>
-        <p:txBody>
-          <a:bodyPr rtlCol="0" anchor="ctr"/>
-          <a:lstStyle/>
-          <a:p>
-            <a:pPr algn="ctr"/>
-            <a:endParaRPr lang="en-IN"/>
-          </a:p>
-        </p:txBody>
-      </p:sp>
-      <p:sp>
-        <p:nvSpPr>
-          <p:cNvPr id="12" name="Google Shape;100;p3"/>
-          <p:cNvSpPr txBox="1"/>
-          <p:nvPr/>
-        </p:nvSpPr>
-        <p:spPr>
-          <a:xfrm>
-            <a:off x="367832" y="1915454"/>
-            <a:ext cx="11764736" cy="4070356"/>
-          </a:xfrm>
-          <a:prstGeom prst="rect">
-            <a:avLst/>
-          </a:prstGeom>
-          <a:noFill/>
-          <a:ln>
-            <a:noFill/>
-          </a:ln>
-        </p:spPr>
-        <p:txBody>
-          <a:bodyPr spcFirstLastPara="1" wrap="square" lIns="91425" tIns="45700" rIns="91425" bIns="45700" anchor="t" anchorCtr="0">
-            <a:noAutofit/>
-          </a:bodyPr>
-          <a:lstStyle/>
-          <a:p>
-            <a:pPr marL="514350" marR="0" lvl="0" indent="-514350" algn="just" rtl="0">
-              <a:lnSpc>
-                <a:spcPct val="90000"/>
-              </a:lnSpc>
-              <a:spcBef>
-                <a:spcPts val="0"/>
-              </a:spcBef>
-              <a:spcAft>
-                <a:spcPts val="0"/>
-              </a:spcAft>
-              <a:buClr>
-                <a:schemeClr val="dk1"/>
-              </a:buClr>
-              <a:buSzPct val="100000"/>
-              <a:buFont typeface="Calibri"/>
-              <a:buAutoNum type="arabicPeriod"/>
-            </a:pPr>
-            <a:r>
-              <a:rPr lang="en-US" b="1" i="0" u="none" strike="noStrike" cap="none" dirty="0">
-                <a:solidFill>
-                  <a:schemeClr val="dk1"/>
-                </a:solidFill>
-                <a:latin typeface="Arial" panose="020B0604020202020204" pitchFamily="34" charset="0"/>
-                <a:ea typeface="Calibri"/>
-                <a:cs typeface="Arial" panose="020B0604020202020204" pitchFamily="34" charset="0"/>
-                <a:sym typeface="Calibri"/>
-              </a:rPr>
-              <a:t>Kindly keep the maximum slides limit up to six </a:t>
-            </a:r>
-            <a:r>
-              <a:rPr lang="en-US" b="1" i="0" u="none" strike="noStrike" cap="none" dirty="0">
-                <a:solidFill>
-                  <a:srgbClr val="C00000"/>
-                </a:solidFill>
-                <a:latin typeface="Arial" panose="020B0604020202020204" pitchFamily="34" charset="0"/>
-                <a:ea typeface="Calibri"/>
-                <a:cs typeface="Arial" panose="020B0604020202020204" pitchFamily="34" charset="0"/>
-                <a:sym typeface="Calibri"/>
-              </a:rPr>
-              <a:t>(6). </a:t>
-            </a:r>
-            <a:r>
-              <a:rPr lang="en-US" b="1" i="0" u="none" strike="noStrike" cap="none" dirty="0">
-                <a:solidFill>
-                  <a:schemeClr val="dk1"/>
-                </a:solidFill>
-                <a:latin typeface="Arial" panose="020B0604020202020204" pitchFamily="34" charset="0"/>
-                <a:ea typeface="Calibri"/>
-                <a:cs typeface="Arial" panose="020B0604020202020204" pitchFamily="34" charset="0"/>
-                <a:sym typeface="Calibri"/>
-              </a:rPr>
-              <a:t>( Including the </a:t>
-            </a:r>
-            <a:r>
-              <a:rPr lang="en-US" b="1" i="0" u="none" strike="noStrike" cap="none">
-                <a:solidFill>
-                  <a:schemeClr val="dk1"/>
-                </a:solidFill>
-                <a:latin typeface="Arial" panose="020B0604020202020204" pitchFamily="34" charset="0"/>
-                <a:ea typeface="Calibri"/>
-                <a:cs typeface="Arial" panose="020B0604020202020204" pitchFamily="34" charset="0"/>
-                <a:sym typeface="Calibri"/>
-              </a:rPr>
-              <a:t>title slide) </a:t>
-            </a:r>
-            <a:endParaRPr b="1" dirty="0">
-              <a:latin typeface="Arial" panose="020B0604020202020204" pitchFamily="34" charset="0"/>
-              <a:cs typeface="Arial" panose="020B0604020202020204" pitchFamily="34" charset="0"/>
-            </a:endParaRPr>
-          </a:p>
-          <a:p>
-            <a:pPr marL="514350" marR="0" lvl="0" indent="-514350" algn="just" rtl="0">
-              <a:lnSpc>
-                <a:spcPct val="90000"/>
-              </a:lnSpc>
-              <a:spcBef>
-                <a:spcPts val="1000"/>
-              </a:spcBef>
-              <a:spcAft>
-                <a:spcPts val="0"/>
-              </a:spcAft>
-              <a:buClr>
-                <a:schemeClr val="dk1"/>
-              </a:buClr>
-              <a:buSzPct val="100000"/>
-              <a:buFont typeface="Calibri"/>
-              <a:buAutoNum type="arabicPeriod"/>
-            </a:pPr>
-            <a:r>
-              <a:rPr lang="en-US" b="1" i="0" u="none" strike="noStrike" cap="none" dirty="0">
-                <a:solidFill>
-                  <a:schemeClr val="dk1"/>
-                </a:solidFill>
-                <a:latin typeface="Arial" panose="020B0604020202020204" pitchFamily="34" charset="0"/>
-                <a:ea typeface="Calibri"/>
-                <a:cs typeface="Arial" panose="020B0604020202020204" pitchFamily="34" charset="0"/>
-                <a:sym typeface="Calibri"/>
-              </a:rPr>
-              <a:t>Try to avoid paragraphs and post your idea in points /diagrams / Infographics /pictures </a:t>
-            </a:r>
-            <a:endParaRPr b="1" dirty="0">
-              <a:latin typeface="Arial" panose="020B0604020202020204" pitchFamily="34" charset="0"/>
-              <a:cs typeface="Arial" panose="020B0604020202020204" pitchFamily="34" charset="0"/>
-            </a:endParaRPr>
-          </a:p>
-          <a:p>
-            <a:pPr marL="514350" marR="0" lvl="0" indent="-514350" algn="just" rtl="0">
-              <a:lnSpc>
-                <a:spcPct val="90000"/>
-              </a:lnSpc>
-              <a:spcBef>
-                <a:spcPts val="1000"/>
-              </a:spcBef>
-              <a:spcAft>
-                <a:spcPts val="0"/>
-              </a:spcAft>
-              <a:buClr>
-                <a:schemeClr val="dk1"/>
-              </a:buClr>
-              <a:buSzPct val="100000"/>
-              <a:buFont typeface="Calibri"/>
-              <a:buAutoNum type="arabicPeriod"/>
-            </a:pPr>
-            <a:r>
-              <a:rPr lang="en-US" b="1" i="0" u="none" strike="noStrike" cap="none" dirty="0">
-                <a:solidFill>
-                  <a:schemeClr val="dk1"/>
-                </a:solidFill>
-                <a:latin typeface="Arial" panose="020B0604020202020204" pitchFamily="34" charset="0"/>
-                <a:ea typeface="Calibri"/>
-                <a:cs typeface="Arial" panose="020B0604020202020204" pitchFamily="34" charset="0"/>
-                <a:sym typeface="Calibri"/>
-              </a:rPr>
-              <a:t>Keep your explanation precise and easy to understand</a:t>
-            </a:r>
-            <a:endParaRPr b="1" dirty="0">
-              <a:latin typeface="Arial" panose="020B0604020202020204" pitchFamily="34" charset="0"/>
-              <a:cs typeface="Arial" panose="020B0604020202020204" pitchFamily="34" charset="0"/>
-            </a:endParaRPr>
-          </a:p>
-          <a:p>
-            <a:pPr marL="514350" marR="0" lvl="0" indent="-514350" algn="just" rtl="0">
-              <a:lnSpc>
-                <a:spcPct val="90000"/>
-              </a:lnSpc>
-              <a:spcBef>
-                <a:spcPts val="1000"/>
-              </a:spcBef>
-              <a:spcAft>
-                <a:spcPts val="0"/>
-              </a:spcAft>
-              <a:buClr>
-                <a:schemeClr val="dk1"/>
-              </a:buClr>
-              <a:buSzPct val="100000"/>
-              <a:buFont typeface="Calibri"/>
-              <a:buAutoNum type="arabicPeriod"/>
-            </a:pPr>
-            <a:r>
-              <a:rPr lang="en-US" b="1" i="0" u="none" strike="noStrike" cap="none" dirty="0">
-                <a:solidFill>
-                  <a:schemeClr val="dk1"/>
-                </a:solidFill>
-                <a:latin typeface="Arial" panose="020B0604020202020204" pitchFamily="34" charset="0"/>
-                <a:ea typeface="Calibri"/>
-                <a:cs typeface="Arial" panose="020B0604020202020204" pitchFamily="34" charset="0"/>
-                <a:sym typeface="Calibri"/>
-              </a:rPr>
-              <a:t>Idea should be unique and novel. </a:t>
-            </a:r>
-            <a:endParaRPr b="1" dirty="0">
-              <a:latin typeface="Arial" panose="020B0604020202020204" pitchFamily="34" charset="0"/>
-              <a:cs typeface="Arial" panose="020B0604020202020204" pitchFamily="34" charset="0"/>
-            </a:endParaRPr>
-          </a:p>
-          <a:p>
-            <a:pPr marL="514350" marR="0" lvl="0" indent="-514350" algn="just" rtl="0">
-              <a:lnSpc>
-                <a:spcPct val="90000"/>
-              </a:lnSpc>
-              <a:spcBef>
-                <a:spcPts val="1000"/>
-              </a:spcBef>
-              <a:spcAft>
-                <a:spcPts val="0"/>
-              </a:spcAft>
-              <a:buClr>
-                <a:schemeClr val="dk1"/>
-              </a:buClr>
-              <a:buSzPct val="100000"/>
-              <a:buFont typeface="Calibri"/>
-              <a:buAutoNum type="arabicPeriod"/>
-            </a:pPr>
-            <a:r>
-              <a:rPr lang="en-US" b="1" i="0" u="none" strike="noStrike" cap="none" dirty="0">
-                <a:solidFill>
-                  <a:schemeClr val="dk1"/>
-                </a:solidFill>
-                <a:latin typeface="Arial" panose="020B0604020202020204" pitchFamily="34" charset="0"/>
-                <a:ea typeface="Calibri"/>
-                <a:cs typeface="Arial" panose="020B0604020202020204" pitchFamily="34" charset="0"/>
-                <a:sym typeface="Calibri"/>
-              </a:rPr>
-              <a:t>You can only use provided </a:t>
-            </a:r>
-            <a:r>
-              <a:rPr lang="en-US" b="1" dirty="0">
-                <a:solidFill>
-                  <a:schemeClr val="dk1"/>
-                </a:solidFill>
-                <a:latin typeface="Arial" panose="020B0604020202020204" pitchFamily="34" charset="0"/>
-                <a:ea typeface="Calibri"/>
-                <a:cs typeface="Arial" panose="020B0604020202020204" pitchFamily="34" charset="0"/>
-                <a:sym typeface="Calibri"/>
-              </a:rPr>
-              <a:t>template</a:t>
-            </a:r>
-            <a:r>
-              <a:rPr lang="en-US" b="1" i="0" u="none" strike="noStrike" cap="none" dirty="0">
-                <a:solidFill>
-                  <a:schemeClr val="dk1"/>
-                </a:solidFill>
-                <a:latin typeface="Arial" panose="020B0604020202020204" pitchFamily="34" charset="0"/>
-                <a:ea typeface="Calibri"/>
-                <a:cs typeface="Arial" panose="020B0604020202020204" pitchFamily="34" charset="0"/>
-                <a:sym typeface="Calibri"/>
-              </a:rPr>
-              <a:t> for making the </a:t>
-            </a:r>
-            <a:r>
-              <a:rPr lang="en-US" b="1" dirty="0">
-                <a:solidFill>
-                  <a:schemeClr val="dk1"/>
-                </a:solidFill>
-                <a:latin typeface="Arial" panose="020B0604020202020204" pitchFamily="34" charset="0"/>
-                <a:ea typeface="Calibri"/>
-                <a:cs typeface="Arial" panose="020B0604020202020204" pitchFamily="34" charset="0"/>
-                <a:sym typeface="Calibri"/>
-              </a:rPr>
-              <a:t>PPT</a:t>
-            </a:r>
-            <a:r>
-              <a:rPr lang="en-US" b="1" i="0" u="none" strike="noStrike" cap="none" dirty="0">
-                <a:solidFill>
-                  <a:schemeClr val="dk1"/>
-                </a:solidFill>
-                <a:latin typeface="Arial" panose="020B0604020202020204" pitchFamily="34" charset="0"/>
-                <a:ea typeface="Calibri"/>
-                <a:cs typeface="Arial" panose="020B0604020202020204" pitchFamily="34" charset="0"/>
-                <a:sym typeface="Calibri"/>
-              </a:rPr>
-              <a:t> without changing the idea details pointers (mentioned in previous slides).</a:t>
-            </a:r>
-            <a:endParaRPr b="1" i="0" u="none" strike="noStrike" cap="none" dirty="0">
-              <a:solidFill>
-                <a:schemeClr val="dk1"/>
-              </a:solidFill>
-              <a:latin typeface="Arial" panose="020B0604020202020204" pitchFamily="34" charset="0"/>
-              <a:ea typeface="Calibri"/>
-              <a:cs typeface="Arial" panose="020B0604020202020204" pitchFamily="34" charset="0"/>
-              <a:sym typeface="Calibri"/>
-            </a:endParaRPr>
-          </a:p>
-          <a:p>
-            <a:pPr marL="514350" marR="0" lvl="0" indent="-514350" algn="just" rtl="0">
-              <a:lnSpc>
-                <a:spcPct val="90000"/>
-              </a:lnSpc>
-              <a:spcBef>
-                <a:spcPts val="1000"/>
-              </a:spcBef>
-              <a:spcAft>
-                <a:spcPts val="0"/>
-              </a:spcAft>
-              <a:buClr>
-                <a:schemeClr val="dk1"/>
-              </a:buClr>
-              <a:buSzPct val="100000"/>
-              <a:buFont typeface="Calibri"/>
-              <a:buAutoNum type="arabicPeriod"/>
-            </a:pPr>
-            <a:r>
-              <a:rPr lang="en-US" b="1" i="0" u="none" strike="noStrike" cap="none" dirty="0">
-                <a:solidFill>
-                  <a:schemeClr val="dk1"/>
-                </a:solidFill>
-                <a:latin typeface="Arial" panose="020B0604020202020204" pitchFamily="34" charset="0"/>
-                <a:ea typeface="Calibri"/>
-                <a:cs typeface="Arial" panose="020B0604020202020204" pitchFamily="34" charset="0"/>
-                <a:sym typeface="Calibri"/>
-              </a:rPr>
-              <a:t>You need to save the file in PDF and upload the same on portal. No PPT, Word Doc or any other format will be supported.</a:t>
-            </a:r>
-            <a:endParaRPr b="1" dirty="0">
-              <a:latin typeface="Arial" panose="020B0604020202020204" pitchFamily="34" charset="0"/>
-              <a:cs typeface="Arial" panose="020B0604020202020204" pitchFamily="34" charset="0"/>
-            </a:endParaRPr>
-          </a:p>
-          <a:p>
-            <a:pPr marL="514350" marR="0" lvl="0" indent="-349885" algn="just" rtl="0">
-              <a:lnSpc>
-                <a:spcPct val="90000"/>
-              </a:lnSpc>
-              <a:spcBef>
-                <a:spcPts val="1000"/>
-              </a:spcBef>
-              <a:spcAft>
-                <a:spcPts val="0"/>
-              </a:spcAft>
-              <a:buClr>
-                <a:schemeClr val="dk1"/>
-              </a:buClr>
-              <a:buSzPct val="100000"/>
-              <a:buFont typeface="Calibri"/>
-              <a:buNone/>
-            </a:pPr>
-            <a:endParaRPr b="1" i="0" u="none" strike="noStrike" cap="none" dirty="0">
-              <a:solidFill>
-                <a:schemeClr val="dk1"/>
-              </a:solidFill>
-              <a:latin typeface="Arial" panose="020B0604020202020204" pitchFamily="34" charset="0"/>
-              <a:ea typeface="Calibri"/>
-              <a:cs typeface="Arial" panose="020B0604020202020204" pitchFamily="34" charset="0"/>
-              <a:sym typeface="Calibri"/>
-            </a:endParaRPr>
-          </a:p>
-          <a:p>
-            <a:pPr marL="0" marR="0" lvl="0" indent="0" algn="just" rtl="0">
-              <a:lnSpc>
-                <a:spcPct val="90000"/>
-              </a:lnSpc>
-              <a:spcBef>
-                <a:spcPts val="1000"/>
-              </a:spcBef>
-              <a:spcAft>
-                <a:spcPts val="0"/>
-              </a:spcAft>
-              <a:buClr>
-                <a:schemeClr val="dk1"/>
-              </a:buClr>
-              <a:buSzPct val="100000"/>
-              <a:buFont typeface="Arial"/>
-              <a:buNone/>
-            </a:pPr>
-            <a:r>
-              <a:rPr lang="en-US" b="1" i="0" u="none" strike="noStrike" cap="none" dirty="0">
-                <a:solidFill>
-                  <a:srgbClr val="C00000"/>
-                </a:solidFill>
-                <a:latin typeface="Arial" panose="020B0604020202020204" pitchFamily="34" charset="0"/>
-                <a:ea typeface="Calibri"/>
-                <a:cs typeface="Arial" panose="020B0604020202020204" pitchFamily="34" charset="0"/>
-                <a:sym typeface="Calibri"/>
-              </a:rPr>
-              <a:t>Note - You can delete this slide (Important Pointers) when you upload the details of your idea on SIH portal.</a:t>
-            </a:r>
-            <a:endParaRPr b="1" dirty="0">
-              <a:solidFill>
-                <a:srgbClr val="C00000"/>
-              </a:solidFill>
-              <a:latin typeface="Arial" panose="020B0604020202020204" pitchFamily="34" charset="0"/>
-              <a:cs typeface="Arial" panose="020B0604020202020204" pitchFamily="34" charset="0"/>
-            </a:endParaRPr>
-          </a:p>
-          <a:p>
-            <a:pPr marL="914400" marR="0" lvl="1" indent="-316230" algn="just" rtl="0">
-              <a:lnSpc>
-                <a:spcPct val="90000"/>
-              </a:lnSpc>
-              <a:spcBef>
-                <a:spcPts val="500"/>
-              </a:spcBef>
-              <a:spcAft>
-                <a:spcPts val="0"/>
-              </a:spcAft>
-              <a:buClr>
-                <a:schemeClr val="dk1"/>
-              </a:buClr>
-              <a:buSzPct val="100000"/>
-              <a:buFont typeface="Calibri"/>
-              <a:buNone/>
-            </a:pPr>
-            <a:endParaRPr sz="2000" b="1" i="0" u="none" strike="noStrike" cap="none" dirty="0">
-              <a:solidFill>
-                <a:schemeClr val="dk1"/>
-              </a:solidFill>
-              <a:latin typeface="Arial" panose="020B0604020202020204" pitchFamily="34" charset="0"/>
-              <a:ea typeface="Calibri"/>
-              <a:cs typeface="Arial" panose="020B0604020202020204" pitchFamily="34" charset="0"/>
-              <a:sym typeface="Calibri"/>
-            </a:endParaRPr>
-          </a:p>
-        </p:txBody>
-      </p:sp>
-      <p:sp>
-        <p:nvSpPr>
-          <p:cNvPr id="4" name="TextBox 3"/>
-          <p:cNvSpPr txBox="1"/>
-          <p:nvPr/>
-        </p:nvSpPr>
-        <p:spPr>
-          <a:xfrm>
-            <a:off x="1393371" y="107066"/>
-            <a:ext cx="8410540" cy="646331"/>
-          </a:xfrm>
-          <a:prstGeom prst="rect">
-            <a:avLst/>
-          </a:prstGeom>
-          <a:noFill/>
-        </p:spPr>
-        <p:txBody>
-          <a:bodyPr wrap="square" rtlCol="0">
-            <a:spAutoFit/>
-          </a:bodyPr>
-          <a:lstStyle/>
-          <a:p>
-            <a:pPr algn="ctr"/>
-            <a:r>
-              <a:rPr lang="en-US" sz="3600" b="1" dirty="0">
-                <a:latin typeface="Times New Roman" panose="02020603050405020304" pitchFamily="18" charset="0"/>
-                <a:cs typeface="Times New Roman" panose="02020603050405020304" pitchFamily="18" charset="0"/>
-              </a:rPr>
-              <a:t>IMPORTANT INSTRUCTIONS</a:t>
-            </a:r>
-            <a:endParaRPr lang="en-IN" sz="3600" b="1" dirty="0">
-              <a:latin typeface="Times New Roman" panose="02020603050405020304" pitchFamily="18" charset="0"/>
-              <a:cs typeface="Times New Roman" panose="02020603050405020304" pitchFamily="18" charset="0"/>
-            </a:endParaRPr>
-          </a:p>
-        </p:txBody>
-      </p:sp>
-      <p:sp>
-        <p:nvSpPr>
-          <p:cNvPr id="5" name="TextBox 4"/>
-          <p:cNvSpPr txBox="1"/>
-          <p:nvPr/>
-        </p:nvSpPr>
-        <p:spPr>
-          <a:xfrm>
-            <a:off x="602343" y="1181900"/>
-            <a:ext cx="9557657" cy="341632"/>
-          </a:xfrm>
-          <a:prstGeom prst="rect">
-            <a:avLst/>
-          </a:prstGeom>
-          <a:noFill/>
-        </p:spPr>
-        <p:txBody>
-          <a:bodyPr wrap="square" rtlCol="0">
-            <a:spAutoFit/>
-          </a:bodyPr>
-          <a:lstStyle/>
-          <a:p>
-            <a:pPr algn="just">
-              <a:lnSpc>
-                <a:spcPct val="90000"/>
-              </a:lnSpc>
-              <a:spcBef>
-                <a:spcPts val="1000"/>
-              </a:spcBef>
-              <a:spcAft>
-                <a:spcPts val="0"/>
-              </a:spcAft>
-              <a:buClr>
-                <a:schemeClr val="dk1"/>
-              </a:buClr>
-              <a:buSzPct val="100000"/>
-            </a:pPr>
-            <a:r>
-              <a:rPr lang="en-US" b="1" dirty="0">
-                <a:solidFill>
-                  <a:schemeClr val="dk1"/>
-                </a:solidFill>
-                <a:latin typeface="Arial" panose="020B0604020202020204" pitchFamily="34" charset="0"/>
-                <a:ea typeface="Calibri"/>
-                <a:cs typeface="Arial" panose="020B0604020202020204" pitchFamily="34" charset="0"/>
-              </a:rPr>
-              <a:t>Please ensure below pointers are met while submitting the Idea PPT:</a:t>
-            </a:r>
-            <a:endParaRPr lang="en-IN" b="1" dirty="0">
-              <a:solidFill>
-                <a:schemeClr val="dk1"/>
-              </a:solidFill>
-              <a:latin typeface="Arial" panose="020B0604020202020204" pitchFamily="34" charset="0"/>
-              <a:ea typeface="Calibri"/>
-              <a:cs typeface="Arial" panose="020B0604020202020204" pitchFamily="34" charset="0"/>
-            </a:endParaRPr>
-          </a:p>
-        </p:txBody>
-      </p:sp>
-      <p:pic>
-        <p:nvPicPr>
-          <p:cNvPr id="13" name="Picture 12"/>
-          <p:cNvPicPr>
-            <a:picLocks noChangeAspect="1"/>
-          </p:cNvPicPr>
-          <p:nvPr/>
-        </p:nvPicPr>
-        <p:blipFill>
-          <a:blip r:embed="rId3">
-            <a:extLst>
-              <a:ext uri="{28A0092B-C50C-407E-A947-70E740481C1C}">
-                <a14:useLocalDpi xmlns:a14="http://schemas.microsoft.com/office/drawing/2010/main" val="0"/>
-              </a:ext>
-            </a:extLst>
-          </a:blip>
-          <a:stretch>
-            <a:fillRect/>
-          </a:stretch>
-        </p:blipFill>
-        <p:spPr>
-          <a:xfrm>
-            <a:off x="9780086" y="1500"/>
-            <a:ext cx="2249850" cy="1062337"/>
-          </a:xfrm>
-          <a:prstGeom prst="rect">
-            <a:avLst/>
-          </a:prstGeom>
-        </p:spPr>
-      </p:pic>
-    </p:spTree>
-    <p:extLst>
-      <p:ext uri="{BB962C8B-B14F-4D97-AF65-F5344CB8AC3E}">
-        <p14:creationId xmlns:p14="http://schemas.microsoft.com/office/powerpoint/2010/main" val="1588084416"/>
       </p:ext>
     </p:extLst>
   </p:cSld>

</xml_diff>